<commit_message>
Update presentation to expanded 10 slides with embedded visual diagrams
</commit_message>
<xml_diff>
--- a/ECommerce_Agentic_AI_Presentation.pptx
+++ b/ECommerce_Agentic_AI_Presentation.pptx
@@ -13,6 +13,8 @@
     <p:sldId id="261" r:id="rId12"/>
     <p:sldId id="262" r:id="rId13"/>
     <p:sldId id="263" r:id="rId14"/>
+    <p:sldId id="264" r:id="rId15"/>
+    <p:sldId id="265" r:id="rId16"/>
   </p:sldIdLst>
   <p:sldSz cx="12191695" cy="6858000" type="screen4x3"/>
   <p:notesSz cx="6858000" cy="9144000"/>
@@ -3235,7 +3237,7 @@
               </a:defRPr>
             </a:pPr>
             <a:r>
-              <a:t>End-to-End Medallion Architecture (Bronze/Silver/Gold) + 9-Agent Autonomous AI System</a:t>
+              <a:t>End-to-End Medallion Data Engineering Pipeline + 9-Agent Autonomous AI Engine</a:t>
             </a:r>
           </a:p>
           <a:p>
@@ -3261,7 +3263,7 @@
 </p:sld>
 </file>
 
-<file path=ppt/slides/slide2.xml><?xml version="1.0" encoding="utf-8"?>
+<file path=ppt/slides/slide10.xml><?xml version="1.0" encoding="utf-8"?>
 <p:sld xmlns:a="http://schemas.openxmlformats.org/drawingml/2006/main" xmlns:p="http://schemas.openxmlformats.org/presentationml/2006/main" xmlns:r="http://schemas.openxmlformats.org/officeDocument/2006/relationships">
   <p:cSld>
     <p:spTree>
@@ -3345,15 +3347,15 @@
               </a:defRPr>
             </a:pPr>
             <a:r>
-              <a:t>1. Problem Statement vs. My Solution</a:t>
+              <a:t>9. Project Evaluation Summary &amp; Live Demo</a:t>
             </a:r>
           </a:p>
           <a:p>
             <a:pPr>
               <a:spcBef>
-                <a:spcPts val="400"/>
+                <a:spcPts val="300"/>
               </a:spcBef>
-              <a:defRPr sz="1200">
+              <a:defRPr sz="1150">
                 <a:solidFill>
                   <a:srgbClr val="94A3B8"/>
                 </a:solidFill>
@@ -3361,7 +3363,7 @@
               </a:defRPr>
             </a:pPr>
             <a:r>
-              <a:t>Why this platform was built and what business value it delivers.</a:t>
+              <a:t>100% operational, fully verified, and ready for live presentation.</a:t>
             </a:r>
           </a:p>
         </p:txBody>
@@ -3409,25 +3411,25 @@
           <a:p>
             <a:pPr algn="ctr">
               <a:spcAft>
-                <a:spcPts val="800"/>
+                <a:spcPts val="600"/>
               </a:spcAft>
-              <a:defRPr sz="1400" b="1">
-                <a:solidFill>
-                  <a:srgbClr val="EF4444"/>
+              <a:defRPr sz="1350" b="1">
+                <a:solidFill>
+                  <a:srgbClr val="10B981"/>
                 </a:solidFill>
                 <a:latin typeface="Arial"/>
               </a:defRPr>
             </a:pPr>
             <a:r>
-              <a:t>❌ THE BUSINESS PROBLEM</a:t>
+              <a:t>⭐ KEY PROJECT HIGHLIGHTS</a:t>
             </a:r>
           </a:p>
           <a:p>
             <a:pPr>
               <a:spcBef>
-                <a:spcPts val="400"/>
+                <a:spcPts val="300"/>
               </a:spcBef>
-              <a:defRPr sz="1050">
+              <a:defRPr sz="1000">
                 <a:solidFill>
                   <a:srgbClr val="F8FAFC"/>
                 </a:solidFill>
@@ -3435,29 +3437,27 @@
               </a:defRPr>
             </a:pPr>
             <a:r>
-              <a:t>1. Raw Data Messiness:</a:t>
-            </a:r>
-            <a:br/>
-            <a:r>
-              <a:t>   E-Commerce stores process thousands of daily orders. Raw data is scattered across files with missing values, invalid dates, and currency errors.</a:t>
-            </a:r>
-            <a:br/>
-            <a:br/>
-            <a:r>
-              <a:t>2. Delay &amp; Reliance on Engineers:</a:t>
-            </a:r>
-            <a:br/>
-            <a:r>
-              <a:t>   Whenever managers need answers (e.g. 'What were sales in California?'), they must wait days for data engineers to write custom database code.</a:t>
-            </a:r>
-            <a:br/>
-            <a:br/>
-            <a:r>
-              <a:t>3. Lack of Actionable Insights:</a:t>
-            </a:r>
-            <a:br/>
-            <a:r>
-              <a:t>   Static spreadsheets show numbers, but fail to explain WHY sales dropped or WHAT management should do next.</a:t>
+              <a:t>• End-to-End Pipeline: Raw data ingested, cleansed in Silver, and modeled into Gold Star Schema (3,938 records).</a:t>
+            </a:r>
+            <a:br/>
+            <a:r>
+              <a:t>• Historical Accuracy: Fully supports SCD Type 1 &amp; Type 2 location history.</a:t>
+            </a:r>
+            <a:br/>
+            <a:r>
+              <a:t>• Robust Data Quality: Great Expectations rules &amp; execution tracking.</a:t>
+            </a:r>
+            <a:br/>
+            <a:r>
+              <a:t>• Autonomous Multi-Agent AI: 9 specialized AI agents collaborating.</a:t>
+            </a:r>
+            <a:br/>
+            <a:r>
+              <a:t>• SQL Security: Enforces strict read-only query validator (blocks DROP, DELETE, etc.).</a:t>
+            </a:r>
+            <a:br/>
+            <a:r>
+              <a:t>• Rate-Limit Protection: Fast pattern fallbacks ensure instant answers (&lt; 1 second).</a:t>
             </a:r>
           </a:p>
         </p:txBody>
@@ -3505,25 +3505,25 @@
           <a:p>
             <a:pPr algn="ctr">
               <a:spcAft>
-                <a:spcPts val="800"/>
+                <a:spcPts val="600"/>
               </a:spcAft>
-              <a:defRPr sz="1400" b="1">
-                <a:solidFill>
-                  <a:srgbClr val="10B981"/>
+              <a:defRPr sz="1350" b="1">
+                <a:solidFill>
+                  <a:srgbClr val="6366F1"/>
                 </a:solidFill>
                 <a:latin typeface="Arial"/>
               </a:defRPr>
             </a:pPr>
             <a:r>
-              <a:t>✅ MY INTEGRATED SOLUTION</a:t>
+              <a:t>🚀 LIVE EVALUATION DEMO URLS</a:t>
             </a:r>
           </a:p>
           <a:p>
             <a:pPr>
               <a:spcBef>
-                <a:spcPts val="400"/>
+                <a:spcPts val="300"/>
               </a:spcBef>
-              <a:defRPr sz="1050">
+              <a:defRPr sz="1000">
                 <a:solidFill>
                   <a:srgbClr val="F8FAFC"/>
                 </a:solidFill>
@@ -3531,29 +3531,41 @@
               </a:defRPr>
             </a:pPr>
             <a:r>
-              <a:t>1. Automated Medallion Pipeline (Layer 1):</a:t>
-            </a:r>
-            <a:br/>
-            <a:r>
-              <a:t>   A 3-tier pipeline (Bronze → Silver → Gold) powered by PostgreSQL and Airflow that automatically cleans data, tracks location history (SCD2), and builds Star Schema tables.</a:t>
-            </a:r>
-            <a:br/>
-            <a:br/>
-            <a:r>
-              <a:t>2. Autonomous Agentic AI Layer (Layer 2):</a:t>
-            </a:r>
-            <a:br/>
-            <a:r>
-              <a:t>   A team of 9 specialized AI agents connected to the Gold database that turns natural English questions into instant SQL queries, Plotly charts, and business recommendations!</a:t>
-            </a:r>
-            <a:br/>
-            <a:br/>
-            <a:r>
-              <a:t>3. Zero Dependency on Data Teams:</a:t>
-            </a:r>
-            <a:br/>
-            <a:r>
-              <a:t>   Managers get instant answers in seconds!</a:t>
+              <a:t>1. Streamlit Application &amp; AI Chatbot:</a:t>
+            </a:r>
+            <a:br/>
+            <a:r>
+              <a:t>   URL:  http://localhost:8501</a:t>
+            </a:r>
+            <a:br/>
+            <a:r>
+              <a:t>   Status:  100% Connected &amp; Ready (All Badges Green 🟢)</a:t>
+            </a:r>
+            <a:br/>
+            <a:br/>
+            <a:r>
+              <a:t>2. Apache Airflow Pipeline Orchestration:</a:t>
+            </a:r>
+            <a:br/>
+            <a:r>
+              <a:t>   URL:  http://localhost:8080</a:t>
+            </a:r>
+            <a:br/>
+            <a:r>
+              <a:t>   User: admin  /  Password: admin123</a:t>
+            </a:r>
+            <a:br/>
+            <a:r>
+              <a:t>   DAGs: 01_bronze_ingestion, 02_silver_transform, 03_gold_aggregation</a:t>
+            </a:r>
+            <a:br/>
+            <a:br/>
+            <a:r>
+              <a:t>3. Comprehensive PDF Report &amp; GitHub Repo:</a:t>
+            </a:r>
+            <a:br/>
+            <a:r>
+              <a:t>   GitHub: https://github.com/Eshaan4/E-COMMERCE-DATA-ENGINEERING-AGENTIC-AI-PLATFORM.git</a:t>
             </a:r>
           </a:p>
         </p:txBody>
@@ -3566,7 +3578,7 @@
 </p:sld>
 </file>
 
-<file path=ppt/slides/slide3.xml><?xml version="1.0" encoding="utf-8"?>
+<file path=ppt/slides/slide2.xml><?xml version="1.0" encoding="utf-8"?>
 <p:sld xmlns:a="http://schemas.openxmlformats.org/drawingml/2006/main" xmlns:p="http://schemas.openxmlformats.org/presentationml/2006/main" xmlns:r="http://schemas.openxmlformats.org/officeDocument/2006/relationships">
   <p:cSld>
     <p:spTree>
@@ -3650,15 +3662,15 @@
               </a:defRPr>
             </a:pPr>
             <a:r>
-              <a:t>2. Data Engineering: 3-Tier Medallion Pipeline</a:t>
+              <a:t>1. Business Problem vs. My Solution</a:t>
             </a:r>
           </a:p>
           <a:p>
             <a:pPr>
               <a:spcBef>
-                <a:spcPts val="400"/>
+                <a:spcPts val="300"/>
               </a:spcBef>
-              <a:defRPr sz="1200">
+              <a:defRPr sz="1150">
                 <a:solidFill>
                   <a:srgbClr val="94A3B8"/>
                 </a:solidFill>
@@ -3666,433 +3678,7 @@
               </a:defRPr>
             </a:pPr>
             <a:r>
-              <a:t>Refining raw data into clean, analytics-ready Star Schema tables.</a:t>
-            </a:r>
-          </a:p>
-        </p:txBody>
-      </p:sp>
-      <p:sp>
-        <p:nvSpPr>
-          <p:cNvPr id="4" name="Rounded Rectangle 3"/>
-          <p:cNvSpPr/>
-          <p:nvPr/>
-        </p:nvSpPr>
-        <p:spPr>
-          <a:xfrm>
-            <a:off x="731520" y="1463040"/>
-            <a:ext cx="3291840" cy="4754880"/>
-          </a:xfrm>
-          <a:prstGeom prst="roundRect">
-            <a:avLst/>
-          </a:prstGeom>
-          <a:solidFill>
-            <a:srgbClr val="1E293B"/>
-          </a:solidFill>
-          <a:ln w="12700">
-            <a:solidFill>
-              <a:srgbClr val="475569"/>
-            </a:solidFill>
-          </a:ln>
-        </p:spPr>
-        <p:style>
-          <a:lnRef idx="1">
-            <a:schemeClr val="accent1"/>
-          </a:lnRef>
-          <a:fillRef idx="3">
-            <a:schemeClr val="accent1"/>
-          </a:fillRef>
-          <a:effectRef idx="2">
-            <a:schemeClr val="accent1"/>
-          </a:effectRef>
-          <a:fontRef idx="minor">
-            <a:schemeClr val="lt1"/>
-          </a:fontRef>
-        </p:style>
-        <p:txBody>
-          <a:bodyPr rtlCol="0" anchor="ctr" wrap="square" lIns="182880" rIns="182880" tIns="182880" bIns="182880"/>
-          <a:lstStyle/>
-          <a:p>
-            <a:pPr algn="ctr">
-              <a:spcAft>
-                <a:spcPts val="800"/>
-              </a:spcAft>
-              <a:defRPr sz="1400" b="1">
-                <a:solidFill>
-                  <a:srgbClr val="D97706"/>
-                </a:solidFill>
-                <a:latin typeface="Arial"/>
-              </a:defRPr>
-            </a:pPr>
-            <a:r>
-              <a:t>🟫 BRONZE LAYER (RAW)</a:t>
-            </a:r>
-          </a:p>
-          <a:p>
-            <a:pPr>
-              <a:spcBef>
-                <a:spcPts val="400"/>
-              </a:spcBef>
-              <a:defRPr sz="1050">
-                <a:solidFill>
-                  <a:srgbClr val="F8FAFC"/>
-                </a:solidFill>
-                <a:latin typeface="Arial"/>
-              </a:defRPr>
-            </a:pPr>
-            <a:r>
-              <a:t>• Append-only storage for original incoming customer files.</a:t>
-            </a:r>
-            <a:br/>
-            <a:r>
-              <a:t>• Preserves exact raw state without modifying values.</a:t>
-            </a:r>
-            <a:br/>
-            <a:r>
-              <a:t>• Includes batch IDs &amp; ingestion timestamps for complete auditability.</a:t>
-            </a:r>
-            <a:br/>
-            <a:br/>
-            <a:r>
-              <a:t>Tables:</a:t>
-            </a:r>
-            <a:br/>
-            <a:r>
-              <a:t>• bronze.customers</a:t>
-            </a:r>
-            <a:br/>
-            <a:r>
-              <a:t>• bronze.orders</a:t>
-            </a:r>
-            <a:br/>
-            <a:r>
-              <a:t>• bronze.order_items</a:t>
-            </a:r>
-            <a:br/>
-            <a:r>
-              <a:t>• bronze.products</a:t>
-            </a:r>
-            <a:br/>
-            <a:r>
-              <a:t>• bronze.sellers</a:t>
-            </a:r>
-            <a:br/>
-            <a:r>
-              <a:t>• bronze.payments</a:t>
-            </a:r>
-          </a:p>
-        </p:txBody>
-      </p:sp>
-      <p:sp>
-        <p:nvSpPr>
-          <p:cNvPr id="5" name="Rounded Rectangle 4"/>
-          <p:cNvSpPr/>
-          <p:nvPr/>
-        </p:nvSpPr>
-        <p:spPr>
-          <a:xfrm>
-            <a:off x="4389120" y="1463040"/>
-            <a:ext cx="3291840" cy="4754880"/>
-          </a:xfrm>
-          <a:prstGeom prst="roundRect">
-            <a:avLst/>
-          </a:prstGeom>
-          <a:solidFill>
-            <a:srgbClr val="1E293B"/>
-          </a:solidFill>
-          <a:ln w="12700">
-            <a:solidFill>
-              <a:srgbClr val="475569"/>
-            </a:solidFill>
-          </a:ln>
-        </p:spPr>
-        <p:style>
-          <a:lnRef idx="1">
-            <a:schemeClr val="accent1"/>
-          </a:lnRef>
-          <a:fillRef idx="3">
-            <a:schemeClr val="accent1"/>
-          </a:fillRef>
-          <a:effectRef idx="2">
-            <a:schemeClr val="accent1"/>
-          </a:effectRef>
-          <a:fontRef idx="minor">
-            <a:schemeClr val="lt1"/>
-          </a:fontRef>
-        </p:style>
-        <p:txBody>
-          <a:bodyPr rtlCol="0" anchor="ctr" wrap="square" lIns="182880" rIns="182880" tIns="182880" bIns="182880"/>
-          <a:lstStyle/>
-          <a:p>
-            <a:pPr algn="ctr">
-              <a:spcAft>
-                <a:spcPts val="800"/>
-              </a:spcAft>
-              <a:defRPr sz="1400" b="1">
-                <a:solidFill>
-                  <a:srgbClr val="94A3B8"/>
-                </a:solidFill>
-                <a:latin typeface="Arial"/>
-              </a:defRPr>
-            </a:pPr>
-            <a:r>
-              <a:t>🥈 SILVER LAYER (CLEANSED)</a:t>
-            </a:r>
-          </a:p>
-          <a:p>
-            <a:pPr>
-              <a:spcBef>
-                <a:spcPts val="400"/>
-              </a:spcBef>
-              <a:defRPr sz="1050">
-                <a:solidFill>
-                  <a:srgbClr val="F8FAFC"/>
-                </a:solidFill>
-                <a:latin typeface="Arial"/>
-              </a:defRPr>
-            </a:pPr>
-            <a:r>
-              <a:t>• Cleans date formats &amp; casts currencies into NUMERIC types.</a:t>
-            </a:r>
-            <a:br/>
-            <a:r>
-              <a:t>• Removes duplicate order rows.</a:t>
-            </a:r>
-            <a:br/>
-            <a:r>
-              <a:t>• Joins product category names with English lookups.</a:t>
-            </a:r>
-            <a:br/>
-            <a:r>
-              <a:t>• Maps customer state codes to geographical regions.</a:t>
-            </a:r>
-            <a:br/>
-            <a:r>
-              <a:t>• Tracks location relocations using SCD Type 2.</a:t>
-            </a:r>
-            <a:br/>
-            <a:br/>
-            <a:r>
-              <a:t>Tables:</a:t>
-            </a:r>
-            <a:br/>
-            <a:r>
-              <a:t>• silver.customers, silver.orders, silver.products, etc.</a:t>
-            </a:r>
-          </a:p>
-        </p:txBody>
-      </p:sp>
-      <p:sp>
-        <p:nvSpPr>
-          <p:cNvPr id="6" name="Rounded Rectangle 5"/>
-          <p:cNvSpPr/>
-          <p:nvPr/>
-        </p:nvSpPr>
-        <p:spPr>
-          <a:xfrm>
-            <a:off x="8046720" y="1463040"/>
-            <a:ext cx="3383280" cy="4754880"/>
-          </a:xfrm>
-          <a:prstGeom prst="roundRect">
-            <a:avLst/>
-          </a:prstGeom>
-          <a:solidFill>
-            <a:srgbClr val="1E293B"/>
-          </a:solidFill>
-          <a:ln w="12700">
-            <a:solidFill>
-              <a:srgbClr val="475569"/>
-            </a:solidFill>
-          </a:ln>
-        </p:spPr>
-        <p:style>
-          <a:lnRef idx="1">
-            <a:schemeClr val="accent1"/>
-          </a:lnRef>
-          <a:fillRef idx="3">
-            <a:schemeClr val="accent1"/>
-          </a:fillRef>
-          <a:effectRef idx="2">
-            <a:schemeClr val="accent1"/>
-          </a:effectRef>
-          <a:fontRef idx="minor">
-            <a:schemeClr val="lt1"/>
-          </a:fontRef>
-        </p:style>
-        <p:txBody>
-          <a:bodyPr rtlCol="0" anchor="ctr" wrap="square" lIns="182880" rIns="182880" tIns="182880" bIns="182880"/>
-          <a:lstStyle/>
-          <a:p>
-            <a:pPr algn="ctr">
-              <a:spcAft>
-                <a:spcPts val="800"/>
-              </a:spcAft>
-              <a:defRPr sz="1400" b="1">
-                <a:solidFill>
-                  <a:srgbClr val="EAB308"/>
-                </a:solidFill>
-                <a:latin typeface="Arial"/>
-              </a:defRPr>
-            </a:pPr>
-            <a:r>
-              <a:t>🥇 GOLD LAYER (ANALYTICS)</a:t>
-            </a:r>
-          </a:p>
-          <a:p>
-            <a:pPr>
-              <a:spcBef>
-                <a:spcPts val="400"/>
-              </a:spcBef>
-              <a:defRPr sz="1050">
-                <a:solidFill>
-                  <a:srgbClr val="F8FAFC"/>
-                </a:solidFill>
-                <a:latin typeface="Arial"/>
-              </a:defRPr>
-            </a:pPr>
-            <a:r>
-              <a:t>• Dimensional Star Schema optimized for high-speed business queries.</a:t>
-            </a:r>
-            <a:br/>
-            <a:r>
-              <a:t>• Central Fact Sales table with surrogate keys.</a:t>
-            </a:r>
-            <a:br/>
-            <a:r>
-              <a:t>• Revenue Mart with SQL window functions (MoM growth %, rank, cumulative revenue).</a:t>
-            </a:r>
-            <a:br/>
-            <a:br/>
-            <a:r>
-              <a:t>Tables:</a:t>
-            </a:r>
-            <a:br/>
-            <a:r>
-              <a:t>• gold.fact_sales</a:t>
-            </a:r>
-            <a:br/>
-            <a:r>
-              <a:t>• gold.dim_customer, dim_product</a:t>
-            </a:r>
-            <a:br/>
-            <a:r>
-              <a:t>• gold.dim_seller, dim_date</a:t>
-            </a:r>
-            <a:br/>
-            <a:r>
-              <a:t>• gold.revenue_mart, kpi_summary</a:t>
-            </a:r>
-          </a:p>
-        </p:txBody>
-      </p:sp>
-    </p:spTree>
-  </p:cSld>
-  <p:clrMapOvr>
-    <a:masterClrMapping/>
-  </p:clrMapOvr>
-</p:sld>
-</file>
-
-<file path=ppt/slides/slide4.xml><?xml version="1.0" encoding="utf-8"?>
-<p:sld xmlns:a="http://schemas.openxmlformats.org/drawingml/2006/main" xmlns:p="http://schemas.openxmlformats.org/presentationml/2006/main" xmlns:r="http://schemas.openxmlformats.org/officeDocument/2006/relationships">
-  <p:cSld>
-    <p:spTree>
-      <p:nvGrpSpPr>
-        <p:cNvPr id="1" name=""/>
-        <p:cNvGrpSpPr/>
-        <p:nvPr/>
-      </p:nvGrpSpPr>
-      <p:grpSpPr/>
-      <p:sp>
-        <p:nvSpPr>
-          <p:cNvPr id="2" name="Rectangle 1"/>
-          <p:cNvSpPr/>
-          <p:nvPr/>
-        </p:nvSpPr>
-        <p:spPr>
-          <a:xfrm>
-            <a:off x="0" y="0"/>
-            <a:ext cx="12191695" cy="6858000"/>
-          </a:xfrm>
-          <a:prstGeom prst="rect">
-            <a:avLst/>
-          </a:prstGeom>
-          <a:solidFill>
-            <a:srgbClr val="0F172A"/>
-          </a:solidFill>
-          <a:ln>
-            <a:noFill/>
-          </a:ln>
-        </p:spPr>
-        <p:style>
-          <a:lnRef idx="1">
-            <a:schemeClr val="accent1"/>
-          </a:lnRef>
-          <a:fillRef idx="3">
-            <a:schemeClr val="accent1"/>
-          </a:fillRef>
-          <a:effectRef idx="2">
-            <a:schemeClr val="accent1"/>
-          </a:effectRef>
-          <a:fontRef idx="minor">
-            <a:schemeClr val="lt1"/>
-          </a:fontRef>
-        </p:style>
-        <p:txBody>
-          <a:bodyPr rtlCol="0" anchor="ctr"/>
-          <a:lstStyle/>
-          <a:p>
-            <a:pPr algn="ctr"/>
-          </a:p>
-        </p:txBody>
-      </p:sp>
-      <p:sp>
-        <p:nvSpPr>
-          <p:cNvPr id="3" name="TextBox 2"/>
-          <p:cNvSpPr txBox="1"/>
-          <p:nvPr/>
-        </p:nvSpPr>
-        <p:spPr>
-          <a:xfrm>
-            <a:off x="731520" y="365760"/>
-            <a:ext cx="10728655" cy="914400"/>
-          </a:xfrm>
-          <a:prstGeom prst="rect">
-            <a:avLst/>
-          </a:prstGeom>
-          <a:noFill/>
-        </p:spPr>
-        <p:txBody>
-          <a:bodyPr wrap="square" lIns="0" tIns="0" rIns="0" bIns="0">
-            <a:spAutoFit/>
-          </a:bodyPr>
-          <a:lstStyle/>
-          <a:p>
-            <a:pPr>
-              <a:defRPr sz="2400" b="1">
-                <a:solidFill>
-                  <a:srgbClr val="F8FAFC"/>
-                </a:solidFill>
-                <a:latin typeface="Arial"/>
-              </a:defRPr>
-            </a:pPr>
-            <a:r>
-              <a:t>3. Historical Tracking (SCD) &amp; Data Quality Rules</a:t>
-            </a:r>
-          </a:p>
-          <a:p>
-            <a:pPr>
-              <a:spcBef>
-                <a:spcPts val="400"/>
-              </a:spcBef>
-              <a:defRPr sz="1200">
-                <a:solidFill>
-                  <a:srgbClr val="94A3B8"/>
-                </a:solidFill>
-                <a:latin typeface="Arial"/>
-              </a:defRPr>
-            </a:pPr>
-            <a:r>
-              <a:t>Ensuring point-in-time revenue accuracy and enforcing data validation.</a:t>
+              <a:t>Why this platform was built and what business value it delivers.</a:t>
             </a:r>
           </a:p>
         </p:txBody>
@@ -4140,25 +3726,25 @@
           <a:p>
             <a:pPr algn="ctr">
               <a:spcAft>
-                <a:spcPts val="800"/>
+                <a:spcPts val="600"/>
               </a:spcAft>
-              <a:defRPr sz="1400" b="1">
-                <a:solidFill>
-                  <a:srgbClr val="6366F1"/>
+              <a:defRPr sz="1350" b="1">
+                <a:solidFill>
+                  <a:srgbClr val="EF4444"/>
                 </a:solidFill>
                 <a:latin typeface="Arial"/>
               </a:defRPr>
             </a:pPr>
             <a:r>
-              <a:t>🔄 SLOWLY CHANGING DIMENSIONS (SCD)</a:t>
+              <a:t>❌ THE BUSINESS PROBLEM</a:t>
             </a:r>
           </a:p>
           <a:p>
             <a:pPr>
               <a:spcBef>
-                <a:spcPts val="400"/>
+                <a:spcPts val="300"/>
               </a:spcBef>
-              <a:defRPr sz="1050">
+              <a:defRPr sz="1000">
                 <a:solidFill>
                   <a:srgbClr val="F8FAFC"/>
                 </a:solidFill>
@@ -4166,40 +3752,29 @@
               </a:defRPr>
             </a:pPr>
             <a:r>
-              <a:t>SCD Type 1 (Overwrite):</a:t>
-            </a:r>
-            <a:br/>
-            <a:r>
-              <a:t>• Target: gold.dim_product</a:t>
-            </a:r>
-            <a:br/>
-            <a:r>
-              <a:t>• Used for basic product updates (weight, size category) where history isn't needed.</a:t>
-            </a:r>
-            <a:br/>
-            <a:r>
-              <a:t>• SQL: ON CONFLICT (product_id) DO UPDATE SET...</a:t>
-            </a:r>
-            <a:br/>
-            <a:br/>
-            <a:r>
-              <a:t>SCD Type 2 (Historical Versioning):</a:t>
-            </a:r>
-            <a:br/>
-            <a:r>
-              <a:t>• Target: gold.dim_customer &amp; gold.dim_seller</a:t>
-            </a:r>
-            <a:br/>
-            <a:r>
-              <a:t>• Tracks relocations across cities/states.</a:t>
-            </a:r>
-            <a:br/>
-            <a:r>
-              <a:t>• Mechanism: Expire old record (is_current = FALSE, end_date = NOW()) and INSERT new record version (is_current = TRUE).</a:t>
-            </a:r>
-            <a:br/>
-            <a:r>
-              <a:t>• Ensures past sales stay credited to the original region!</a:t>
+              <a:t>1. Raw Data Messiness:</a:t>
+            </a:r>
+            <a:br/>
+            <a:r>
+              <a:t>   E-Commerce stores process thousands of daily orders. Raw data is scattered across files with missing values, invalid dates, and currency errors.</a:t>
+            </a:r>
+            <a:br/>
+            <a:br/>
+            <a:r>
+              <a:t>2. Delay &amp; Reliance on Engineers:</a:t>
+            </a:r>
+            <a:br/>
+            <a:r>
+              <a:t>   Whenever managers need answers (e.g. 'What were sales in California?'), they must wait days for data engineers to write custom database code.</a:t>
+            </a:r>
+            <a:br/>
+            <a:br/>
+            <a:r>
+              <a:t>3. Lack of Actionable Insights:</a:t>
+            </a:r>
+            <a:br/>
+            <a:r>
+              <a:t>   Static spreadsheets show numbers, but fail to explain WHY sales dropped or WHAT management should do next.</a:t>
             </a:r>
           </a:p>
         </p:txBody>
@@ -4247,9 +3822,9 @@
           <a:p>
             <a:pPr algn="ctr">
               <a:spcAft>
-                <a:spcPts val="800"/>
+                <a:spcPts val="600"/>
               </a:spcAft>
-              <a:defRPr sz="1400" b="1">
+              <a:defRPr sz="1350" b="1">
                 <a:solidFill>
                   <a:srgbClr val="10B981"/>
                 </a:solidFill>
@@ -4257,15 +3832,550 @@
               </a:defRPr>
             </a:pPr>
             <a:r>
-              <a:t>🛡️ DATA QUALITY &amp; METADATA AUDITING</a:t>
+              <a:t>✅ MY INTEGRATED SOLUTION</a:t>
             </a:r>
           </a:p>
           <a:p>
             <a:pPr>
               <a:spcBef>
-                <a:spcPts val="400"/>
+                <a:spcPts val="300"/>
               </a:spcBef>
-              <a:defRPr sz="1050">
+              <a:defRPr sz="1000">
+                <a:solidFill>
+                  <a:srgbClr val="F8FAFC"/>
+                </a:solidFill>
+                <a:latin typeface="Arial"/>
+              </a:defRPr>
+            </a:pPr>
+            <a:r>
+              <a:t>1. Automated Medallion Pipeline (Layer 1):</a:t>
+            </a:r>
+            <a:br/>
+            <a:r>
+              <a:t>   A 3-tier pipeline (Bronze → Silver → Gold) powered by PostgreSQL and Airflow that automatically cleans data, tracks location history (SCD2), and builds Star Schema tables.</a:t>
+            </a:r>
+            <a:br/>
+            <a:br/>
+            <a:r>
+              <a:t>2. Autonomous Agentic AI Layer (Layer 2):</a:t>
+            </a:r>
+            <a:br/>
+            <a:r>
+              <a:t>   A team of 9 specialized AI agents connected to the Gold database that turns natural English questions into instant SQL queries, Plotly charts, and business recommendations!</a:t>
+            </a:r>
+            <a:br/>
+            <a:br/>
+            <a:r>
+              <a:t>3. Zero Dependency on Data Teams:</a:t>
+            </a:r>
+            <a:br/>
+            <a:r>
+              <a:t>   Managers get instant answers in seconds!</a:t>
+            </a:r>
+          </a:p>
+        </p:txBody>
+      </p:sp>
+    </p:spTree>
+  </p:cSld>
+  <p:clrMapOvr>
+    <a:masterClrMapping/>
+  </p:clrMapOvr>
+</p:sld>
+</file>
+
+<file path=ppt/slides/slide3.xml><?xml version="1.0" encoding="utf-8"?>
+<p:sld xmlns:a="http://schemas.openxmlformats.org/drawingml/2006/main" xmlns:p="http://schemas.openxmlformats.org/presentationml/2006/main" xmlns:r="http://schemas.openxmlformats.org/officeDocument/2006/relationships">
+  <p:cSld>
+    <p:spTree>
+      <p:nvGrpSpPr>
+        <p:cNvPr id="1" name=""/>
+        <p:cNvGrpSpPr/>
+        <p:nvPr/>
+      </p:nvGrpSpPr>
+      <p:grpSpPr/>
+      <p:sp>
+        <p:nvSpPr>
+          <p:cNvPr id="2" name="Rectangle 1"/>
+          <p:cNvSpPr/>
+          <p:nvPr/>
+        </p:nvSpPr>
+        <p:spPr>
+          <a:xfrm>
+            <a:off x="0" y="0"/>
+            <a:ext cx="12191695" cy="6858000"/>
+          </a:xfrm>
+          <a:prstGeom prst="rect">
+            <a:avLst/>
+          </a:prstGeom>
+          <a:solidFill>
+            <a:srgbClr val="0F172A"/>
+          </a:solidFill>
+          <a:ln>
+            <a:noFill/>
+          </a:ln>
+        </p:spPr>
+        <p:style>
+          <a:lnRef idx="1">
+            <a:schemeClr val="accent1"/>
+          </a:lnRef>
+          <a:fillRef idx="3">
+            <a:schemeClr val="accent1"/>
+          </a:fillRef>
+          <a:effectRef idx="2">
+            <a:schemeClr val="accent1"/>
+          </a:effectRef>
+          <a:fontRef idx="minor">
+            <a:schemeClr val="lt1"/>
+          </a:fontRef>
+        </p:style>
+        <p:txBody>
+          <a:bodyPr rtlCol="0" anchor="ctr"/>
+          <a:lstStyle/>
+          <a:p>
+            <a:pPr algn="ctr"/>
+          </a:p>
+        </p:txBody>
+      </p:sp>
+      <p:sp>
+        <p:nvSpPr>
+          <p:cNvPr id="3" name="TextBox 2"/>
+          <p:cNvSpPr txBox="1"/>
+          <p:nvPr/>
+        </p:nvSpPr>
+        <p:spPr>
+          <a:xfrm>
+            <a:off x="731520" y="365760"/>
+            <a:ext cx="10728655" cy="914400"/>
+          </a:xfrm>
+          <a:prstGeom prst="rect">
+            <a:avLst/>
+          </a:prstGeom>
+          <a:noFill/>
+        </p:spPr>
+        <p:txBody>
+          <a:bodyPr wrap="square" lIns="0" tIns="0" rIns="0" bIns="0">
+            <a:spAutoFit/>
+          </a:bodyPr>
+          <a:lstStyle/>
+          <a:p>
+            <a:pPr>
+              <a:defRPr sz="2400" b="1">
+                <a:solidFill>
+                  <a:srgbClr val="F8FAFC"/>
+                </a:solidFill>
+                <a:latin typeface="Arial"/>
+              </a:defRPr>
+            </a:pPr>
+            <a:r>
+              <a:t>2. Data Engineering: Medallion Architecture</a:t>
+            </a:r>
+          </a:p>
+          <a:p>
+            <a:pPr>
+              <a:spcBef>
+                <a:spcPts val="300"/>
+              </a:spcBef>
+              <a:defRPr sz="1150">
+                <a:solidFill>
+                  <a:srgbClr val="94A3B8"/>
+                </a:solidFill>
+                <a:latin typeface="Arial"/>
+              </a:defRPr>
+            </a:pPr>
+            <a:r>
+              <a:t>Refining raw incoming data into pure, analytics-ready Star Schema tables.</a:t>
+            </a:r>
+          </a:p>
+        </p:txBody>
+      </p:sp>
+      <p:pic>
+        <p:nvPicPr>
+          <p:cNvPr id="4" name="Picture 3" descr="medallion_diagram.png"/>
+          <p:cNvPicPr>
+            <a:picLocks noChangeAspect="1"/>
+          </p:cNvPicPr>
+          <p:nvPr/>
+        </p:nvPicPr>
+        <p:blipFill>
+          <a:blip r:embed="rId2"/>
+          <a:stretch>
+            <a:fillRect/>
+          </a:stretch>
+        </p:blipFill>
+        <p:spPr>
+          <a:xfrm>
+            <a:off x="731520" y="1371600"/>
+            <a:ext cx="10728655" cy="1220940"/>
+          </a:xfrm>
+          <a:prstGeom prst="rect">
+            <a:avLst/>
+          </a:prstGeom>
+        </p:spPr>
+      </p:pic>
+      <p:sp>
+        <p:nvSpPr>
+          <p:cNvPr id="5" name="Rounded Rectangle 4"/>
+          <p:cNvSpPr/>
+          <p:nvPr/>
+        </p:nvSpPr>
+        <p:spPr>
+          <a:xfrm>
+            <a:off x="731520" y="4114800"/>
+            <a:ext cx="10728655" cy="2103120"/>
+          </a:xfrm>
+          <a:prstGeom prst="roundRect">
+            <a:avLst/>
+          </a:prstGeom>
+          <a:solidFill>
+            <a:srgbClr val="1E293B"/>
+          </a:solidFill>
+          <a:ln w="12700">
+            <a:solidFill>
+              <a:srgbClr val="475569"/>
+            </a:solidFill>
+          </a:ln>
+        </p:spPr>
+        <p:style>
+          <a:lnRef idx="1">
+            <a:schemeClr val="accent1"/>
+          </a:lnRef>
+          <a:fillRef idx="3">
+            <a:schemeClr val="accent1"/>
+          </a:fillRef>
+          <a:effectRef idx="2">
+            <a:schemeClr val="accent1"/>
+          </a:effectRef>
+          <a:fontRef idx="minor">
+            <a:schemeClr val="lt1"/>
+          </a:fontRef>
+        </p:style>
+        <p:txBody>
+          <a:bodyPr rtlCol="0" anchor="ctr" wrap="square" lIns="182880" rIns="182880" tIns="182880" bIns="182880"/>
+          <a:lstStyle/>
+          <a:p>
+            <a:pPr algn="ctr">
+              <a:spcAft>
+                <a:spcPts val="600"/>
+              </a:spcAft>
+              <a:defRPr sz="1350" b="1">
+                <a:solidFill>
+                  <a:srgbClr val="6366F1"/>
+                </a:solidFill>
+                <a:latin typeface="Arial"/>
+              </a:defRPr>
+            </a:pPr>
+            <a:r>
+              <a:t>MEDALLION PIPELINE BREAKDOWN</a:t>
+            </a:r>
+          </a:p>
+          <a:p>
+            <a:pPr>
+              <a:spcBef>
+                <a:spcPts val="300"/>
+              </a:spcBef>
+              <a:defRPr sz="1000">
+                <a:solidFill>
+                  <a:srgbClr val="F8FAFC"/>
+                </a:solidFill>
+                <a:latin typeface="Arial"/>
+              </a:defRPr>
+            </a:pPr>
+            <a:r>
+              <a:t>• Bronze Layer (🟫 Raw): Append-only storage for original customer order feeds. Preserves raw state with batch IDs and timestamps.</a:t>
+            </a:r>
+            <a:br/>
+            <a:r>
+              <a:t>• Silver Layer (🥈 Cleansed): Standardizes date formats, cleans currencies, removes duplicates, translates categories to English, and tracks SCD Type 2.</a:t>
+            </a:r>
+            <a:br/>
+            <a:r>
+              <a:t>• Gold Layer (🥇 Analytics Star Schema): Optimized dimensional star schema (fact_sales, dim_customer, dim_product, dim_seller, dim_date, revenue_mart).</a:t>
+            </a:r>
+          </a:p>
+        </p:txBody>
+      </p:sp>
+    </p:spTree>
+  </p:cSld>
+  <p:clrMapOvr>
+    <a:masterClrMapping/>
+  </p:clrMapOvr>
+</p:sld>
+</file>
+
+<file path=ppt/slides/slide4.xml><?xml version="1.0" encoding="utf-8"?>
+<p:sld xmlns:a="http://schemas.openxmlformats.org/drawingml/2006/main" xmlns:p="http://schemas.openxmlformats.org/presentationml/2006/main" xmlns:r="http://schemas.openxmlformats.org/officeDocument/2006/relationships">
+  <p:cSld>
+    <p:spTree>
+      <p:nvGrpSpPr>
+        <p:cNvPr id="1" name=""/>
+        <p:cNvGrpSpPr/>
+        <p:nvPr/>
+      </p:nvGrpSpPr>
+      <p:grpSpPr/>
+      <p:sp>
+        <p:nvSpPr>
+          <p:cNvPr id="2" name="Rectangle 1"/>
+          <p:cNvSpPr/>
+          <p:nvPr/>
+        </p:nvSpPr>
+        <p:spPr>
+          <a:xfrm>
+            <a:off x="0" y="0"/>
+            <a:ext cx="12191695" cy="6858000"/>
+          </a:xfrm>
+          <a:prstGeom prst="rect">
+            <a:avLst/>
+          </a:prstGeom>
+          <a:solidFill>
+            <a:srgbClr val="0F172A"/>
+          </a:solidFill>
+          <a:ln>
+            <a:noFill/>
+          </a:ln>
+        </p:spPr>
+        <p:style>
+          <a:lnRef idx="1">
+            <a:schemeClr val="accent1"/>
+          </a:lnRef>
+          <a:fillRef idx="3">
+            <a:schemeClr val="accent1"/>
+          </a:fillRef>
+          <a:effectRef idx="2">
+            <a:schemeClr val="accent1"/>
+          </a:effectRef>
+          <a:fontRef idx="minor">
+            <a:schemeClr val="lt1"/>
+          </a:fontRef>
+        </p:style>
+        <p:txBody>
+          <a:bodyPr rtlCol="0" anchor="ctr"/>
+          <a:lstStyle/>
+          <a:p>
+            <a:pPr algn="ctr"/>
+          </a:p>
+        </p:txBody>
+      </p:sp>
+      <p:sp>
+        <p:nvSpPr>
+          <p:cNvPr id="3" name="TextBox 2"/>
+          <p:cNvSpPr txBox="1"/>
+          <p:nvPr/>
+        </p:nvSpPr>
+        <p:spPr>
+          <a:xfrm>
+            <a:off x="731520" y="365760"/>
+            <a:ext cx="10728655" cy="914400"/>
+          </a:xfrm>
+          <a:prstGeom prst="rect">
+            <a:avLst/>
+          </a:prstGeom>
+          <a:noFill/>
+        </p:spPr>
+        <p:txBody>
+          <a:bodyPr wrap="square" lIns="0" tIns="0" rIns="0" bIns="0">
+            <a:spAutoFit/>
+          </a:bodyPr>
+          <a:lstStyle/>
+          <a:p>
+            <a:pPr>
+              <a:defRPr sz="2400" b="1">
+                <a:solidFill>
+                  <a:srgbClr val="F8FAFC"/>
+                </a:solidFill>
+                <a:latin typeface="Arial"/>
+              </a:defRPr>
+            </a:pPr>
+            <a:r>
+              <a:t>3. Historical Tracking (SCD) &amp; Data Quality Rules</a:t>
+            </a:r>
+          </a:p>
+          <a:p>
+            <a:pPr>
+              <a:spcBef>
+                <a:spcPts val="300"/>
+              </a:spcBef>
+              <a:defRPr sz="1150">
+                <a:solidFill>
+                  <a:srgbClr val="94A3B8"/>
+                </a:solidFill>
+                <a:latin typeface="Arial"/>
+              </a:defRPr>
+            </a:pPr>
+            <a:r>
+              <a:t>Ensuring point-in-time revenue accuracy and enforcing data validation.</a:t>
+            </a:r>
+          </a:p>
+        </p:txBody>
+      </p:sp>
+      <p:sp>
+        <p:nvSpPr>
+          <p:cNvPr id="4" name="Rounded Rectangle 3"/>
+          <p:cNvSpPr/>
+          <p:nvPr/>
+        </p:nvSpPr>
+        <p:spPr>
+          <a:xfrm>
+            <a:off x="731520" y="1463040"/>
+            <a:ext cx="5120640" cy="4754880"/>
+          </a:xfrm>
+          <a:prstGeom prst="roundRect">
+            <a:avLst/>
+          </a:prstGeom>
+          <a:solidFill>
+            <a:srgbClr val="1E293B"/>
+          </a:solidFill>
+          <a:ln w="12700">
+            <a:solidFill>
+              <a:srgbClr val="475569"/>
+            </a:solidFill>
+          </a:ln>
+        </p:spPr>
+        <p:style>
+          <a:lnRef idx="1">
+            <a:schemeClr val="accent1"/>
+          </a:lnRef>
+          <a:fillRef idx="3">
+            <a:schemeClr val="accent1"/>
+          </a:fillRef>
+          <a:effectRef idx="2">
+            <a:schemeClr val="accent1"/>
+          </a:effectRef>
+          <a:fontRef idx="minor">
+            <a:schemeClr val="lt1"/>
+          </a:fontRef>
+        </p:style>
+        <p:txBody>
+          <a:bodyPr rtlCol="0" anchor="ctr" wrap="square" lIns="182880" rIns="182880" tIns="182880" bIns="182880"/>
+          <a:lstStyle/>
+          <a:p>
+            <a:pPr algn="ctr">
+              <a:spcAft>
+                <a:spcPts val="600"/>
+              </a:spcAft>
+              <a:defRPr sz="1350" b="1">
+                <a:solidFill>
+                  <a:srgbClr val="6366F1"/>
+                </a:solidFill>
+                <a:latin typeface="Arial"/>
+              </a:defRPr>
+            </a:pPr>
+            <a:r>
+              <a:t>🔄 SLOWLY CHANGING DIMENSIONS (SCD)</a:t>
+            </a:r>
+          </a:p>
+          <a:p>
+            <a:pPr>
+              <a:spcBef>
+                <a:spcPts val="300"/>
+              </a:spcBef>
+              <a:defRPr sz="1000">
+                <a:solidFill>
+                  <a:srgbClr val="F8FAFC"/>
+                </a:solidFill>
+                <a:latin typeface="Arial"/>
+              </a:defRPr>
+            </a:pPr>
+            <a:r>
+              <a:t>SCD Type 1 (Overwrite):</a:t>
+            </a:r>
+            <a:br/>
+            <a:r>
+              <a:t>• Target: gold.dim_product</a:t>
+            </a:r>
+            <a:br/>
+            <a:r>
+              <a:t>• Used for basic product updates (weight, size category) where history isn't needed.</a:t>
+            </a:r>
+            <a:br/>
+            <a:r>
+              <a:t>• SQL: ON CONFLICT (product_id) DO UPDATE SET...</a:t>
+            </a:r>
+            <a:br/>
+            <a:br/>
+            <a:r>
+              <a:t>SCD Type 2 (Historical Versioning):</a:t>
+            </a:r>
+            <a:br/>
+            <a:r>
+              <a:t>• Target: gold.dim_customer &amp; gold.dim_seller</a:t>
+            </a:r>
+            <a:br/>
+            <a:r>
+              <a:t>• Tracks relocations across cities/states.</a:t>
+            </a:r>
+            <a:br/>
+            <a:r>
+              <a:t>• Mechanism: Expire old record (is_current = FALSE, end_date = NOW()) and INSERT new record version (is_current = TRUE).</a:t>
+            </a:r>
+            <a:br/>
+            <a:r>
+              <a:t>• Guarantees past sales stay credited to original regions!</a:t>
+            </a:r>
+          </a:p>
+        </p:txBody>
+      </p:sp>
+      <p:sp>
+        <p:nvSpPr>
+          <p:cNvPr id="5" name="Rounded Rectangle 4"/>
+          <p:cNvSpPr/>
+          <p:nvPr/>
+        </p:nvSpPr>
+        <p:spPr>
+          <a:xfrm>
+            <a:off x="6217920" y="1463040"/>
+            <a:ext cx="5212080" cy="4754880"/>
+          </a:xfrm>
+          <a:prstGeom prst="roundRect">
+            <a:avLst/>
+          </a:prstGeom>
+          <a:solidFill>
+            <a:srgbClr val="1E293B"/>
+          </a:solidFill>
+          <a:ln w="12700">
+            <a:solidFill>
+              <a:srgbClr val="475569"/>
+            </a:solidFill>
+          </a:ln>
+        </p:spPr>
+        <p:style>
+          <a:lnRef idx="1">
+            <a:schemeClr val="accent1"/>
+          </a:lnRef>
+          <a:fillRef idx="3">
+            <a:schemeClr val="accent1"/>
+          </a:fillRef>
+          <a:effectRef idx="2">
+            <a:schemeClr val="accent1"/>
+          </a:effectRef>
+          <a:fontRef idx="minor">
+            <a:schemeClr val="lt1"/>
+          </a:fontRef>
+        </p:style>
+        <p:txBody>
+          <a:bodyPr rtlCol="0" anchor="ctr" wrap="square" lIns="182880" rIns="182880" tIns="182880" bIns="182880"/>
+          <a:lstStyle/>
+          <a:p>
+            <a:pPr algn="ctr">
+              <a:spcAft>
+                <a:spcPts val="600"/>
+              </a:spcAft>
+              <a:defRPr sz="1350" b="1">
+                <a:solidFill>
+                  <a:srgbClr val="10B981"/>
+                </a:solidFill>
+                <a:latin typeface="Arial"/>
+              </a:defRPr>
+            </a:pPr>
+            <a:r>
+              <a:t>🛡️ DATA QUALITY &amp; METADATA AUDITING</a:t>
+            </a:r>
+          </a:p>
+          <a:p>
+            <a:pPr>
+              <a:spcBef>
+                <a:spcPts val="300"/>
+              </a:spcBef>
+              <a:defRPr sz="1000">
                 <a:solidFill>
                   <a:srgbClr val="F8FAFC"/>
                 </a:solidFill>
@@ -4401,15 +4511,15 @@
               </a:defRPr>
             </a:pPr>
             <a:r>
-              <a:t>4. Agentic AI Architecture: 9 Specialist Agents</a:t>
+              <a:t>4. Data Science &amp; ML Engine</a:t>
             </a:r>
           </a:p>
           <a:p>
             <a:pPr>
               <a:spcBef>
-                <a:spcPts val="400"/>
+                <a:spcPts val="300"/>
               </a:spcBef>
-              <a:defRPr sz="1200">
+              <a:defRPr sz="1150">
                 <a:solidFill>
                   <a:srgbClr val="94A3B8"/>
                 </a:solidFill>
@@ -4417,7 +4527,249 @@
               </a:defRPr>
             </a:pPr>
             <a:r>
-              <a:t>A team of autonomous AI agents collaborating to answer business questions.</a:t>
+              <a:t>Regression trends, moving averages, Z-score anomaly detection, and linear forecasting.</a:t>
+            </a:r>
+          </a:p>
+        </p:txBody>
+      </p:sp>
+      <p:sp>
+        <p:nvSpPr>
+          <p:cNvPr id="4" name="Rounded Rectangle 3"/>
+          <p:cNvSpPr/>
+          <p:nvPr/>
+        </p:nvSpPr>
+        <p:spPr>
+          <a:xfrm>
+            <a:off x="731520" y="1463040"/>
+            <a:ext cx="4937760" cy="4754880"/>
+          </a:xfrm>
+          <a:prstGeom prst="roundRect">
+            <a:avLst/>
+          </a:prstGeom>
+          <a:solidFill>
+            <a:srgbClr val="1E293B"/>
+          </a:solidFill>
+          <a:ln w="12700">
+            <a:solidFill>
+              <a:srgbClr val="475569"/>
+            </a:solidFill>
+          </a:ln>
+        </p:spPr>
+        <p:style>
+          <a:lnRef idx="1">
+            <a:schemeClr val="accent1"/>
+          </a:lnRef>
+          <a:fillRef idx="3">
+            <a:schemeClr val="accent1"/>
+          </a:fillRef>
+          <a:effectRef idx="2">
+            <a:schemeClr val="accent1"/>
+          </a:effectRef>
+          <a:fontRef idx="minor">
+            <a:schemeClr val="lt1"/>
+          </a:fontRef>
+        </p:style>
+        <p:txBody>
+          <a:bodyPr rtlCol="0" anchor="ctr" wrap="square" lIns="182880" rIns="182880" tIns="182880" bIns="182880"/>
+          <a:lstStyle/>
+          <a:p>
+            <a:pPr algn="ctr">
+              <a:spcAft>
+                <a:spcPts val="600"/>
+              </a:spcAft>
+              <a:defRPr sz="1350" b="1">
+                <a:solidFill>
+                  <a:srgbClr val="6366F1"/>
+                </a:solidFill>
+                <a:latin typeface="Arial"/>
+              </a:defRPr>
+            </a:pPr>
+            <a:r>
+              <a:t>🧠 STATISTICAL &amp; ML CAPABILITIES</a:t>
+            </a:r>
+          </a:p>
+          <a:p>
+            <a:pPr>
+              <a:spcBef>
+                <a:spcPts val="300"/>
+              </a:spcBef>
+              <a:defRPr sz="1000">
+                <a:solidFill>
+                  <a:srgbClr val="F8FAFC"/>
+                </a:solidFill>
+                <a:latin typeface="Arial"/>
+              </a:defRPr>
+            </a:pPr>
+            <a:r>
+              <a:t>1. Linear Trend Regression:</a:t>
+            </a:r>
+            <a:br/>
+            <a:r>
+              <a:t>   Computes regression slopes on monthly revenue time-series to determine whether sales trajectories are increasing or decreasing.</a:t>
+            </a:r>
+            <a:br/>
+            <a:br/>
+            <a:r>
+              <a:t>2. Z-Score Anomaly Detection:</a:t>
+            </a:r>
+            <a:br/>
+            <a:r>
+              <a:t>   Calculates statistical Z-scores across monthly revenue. Months where |Z| &gt; 2.0 are flagged as revenue anomalies.</a:t>
+            </a:r>
+            <a:br/>
+            <a:br/>
+            <a:r>
+              <a:t>3. Revenue Forecasting:</a:t>
+            </a:r>
+            <a:br/>
+            <a:r>
+              <a:t>   Extrapolates sales for 1 to 12 months ahead using linear regression extrapolation (numpy.polyfit).</a:t>
+            </a:r>
+            <a:br/>
+            <a:br/>
+            <a:r>
+              <a:t>4. 3-Period Moving Average:</a:t>
+            </a:r>
+            <a:br/>
+            <a:r>
+              <a:t>   Smooths short-term fluctuations to reveal underlying growth.</a:t>
+            </a:r>
+          </a:p>
+        </p:txBody>
+      </p:sp>
+      <p:pic>
+        <p:nvPicPr>
+          <p:cNvPr id="5" name="Picture 4" descr="forecast_chart.png"/>
+          <p:cNvPicPr>
+            <a:picLocks noChangeAspect="1"/>
+          </p:cNvPicPr>
+          <p:nvPr/>
+        </p:nvPicPr>
+        <p:blipFill>
+          <a:blip r:embed="rId2"/>
+          <a:stretch>
+            <a:fillRect/>
+          </a:stretch>
+        </p:blipFill>
+        <p:spPr>
+          <a:xfrm>
+            <a:off x="5852160" y="1463040"/>
+            <a:ext cx="5577840" cy="2753617"/>
+          </a:xfrm>
+          <a:prstGeom prst="rect">
+            <a:avLst/>
+          </a:prstGeom>
+        </p:spPr>
+      </p:pic>
+    </p:spTree>
+  </p:cSld>
+  <p:clrMapOvr>
+    <a:masterClrMapping/>
+  </p:clrMapOvr>
+</p:sld>
+</file>
+
+<file path=ppt/slides/slide6.xml><?xml version="1.0" encoding="utf-8"?>
+<p:sld xmlns:a="http://schemas.openxmlformats.org/drawingml/2006/main" xmlns:p="http://schemas.openxmlformats.org/presentationml/2006/main" xmlns:r="http://schemas.openxmlformats.org/officeDocument/2006/relationships">
+  <p:cSld>
+    <p:spTree>
+      <p:nvGrpSpPr>
+        <p:cNvPr id="1" name=""/>
+        <p:cNvGrpSpPr/>
+        <p:nvPr/>
+      </p:nvGrpSpPr>
+      <p:grpSpPr/>
+      <p:sp>
+        <p:nvSpPr>
+          <p:cNvPr id="2" name="Rectangle 1"/>
+          <p:cNvSpPr/>
+          <p:nvPr/>
+        </p:nvSpPr>
+        <p:spPr>
+          <a:xfrm>
+            <a:off x="0" y="0"/>
+            <a:ext cx="12191695" cy="6858000"/>
+          </a:xfrm>
+          <a:prstGeom prst="rect">
+            <a:avLst/>
+          </a:prstGeom>
+          <a:solidFill>
+            <a:srgbClr val="0F172A"/>
+          </a:solidFill>
+          <a:ln>
+            <a:noFill/>
+          </a:ln>
+        </p:spPr>
+        <p:style>
+          <a:lnRef idx="1">
+            <a:schemeClr val="accent1"/>
+          </a:lnRef>
+          <a:fillRef idx="3">
+            <a:schemeClr val="accent1"/>
+          </a:fillRef>
+          <a:effectRef idx="2">
+            <a:schemeClr val="accent1"/>
+          </a:effectRef>
+          <a:fontRef idx="minor">
+            <a:schemeClr val="lt1"/>
+          </a:fontRef>
+        </p:style>
+        <p:txBody>
+          <a:bodyPr rtlCol="0" anchor="ctr"/>
+          <a:lstStyle/>
+          <a:p>
+            <a:pPr algn="ctr"/>
+          </a:p>
+        </p:txBody>
+      </p:sp>
+      <p:sp>
+        <p:nvSpPr>
+          <p:cNvPr id="3" name="TextBox 2"/>
+          <p:cNvSpPr txBox="1"/>
+          <p:nvPr/>
+        </p:nvSpPr>
+        <p:spPr>
+          <a:xfrm>
+            <a:off x="731520" y="365760"/>
+            <a:ext cx="10728655" cy="914400"/>
+          </a:xfrm>
+          <a:prstGeom prst="rect">
+            <a:avLst/>
+          </a:prstGeom>
+          <a:noFill/>
+        </p:spPr>
+        <p:txBody>
+          <a:bodyPr wrap="square" lIns="0" tIns="0" rIns="0" bIns="0">
+            <a:spAutoFit/>
+          </a:bodyPr>
+          <a:lstStyle/>
+          <a:p>
+            <a:pPr>
+              <a:defRPr sz="2400" b="1">
+                <a:solidFill>
+                  <a:srgbClr val="F8FAFC"/>
+                </a:solidFill>
+                <a:latin typeface="Arial"/>
+              </a:defRPr>
+            </a:pPr>
+            <a:r>
+              <a:t>5. Agentic AI System: 9 Specialist Agents</a:t>
+            </a:r>
+          </a:p>
+          <a:p>
+            <a:pPr>
+              <a:spcBef>
+                <a:spcPts val="300"/>
+              </a:spcBef>
+              <a:defRPr sz="1150">
+                <a:solidFill>
+                  <a:srgbClr val="94A3B8"/>
+                </a:solidFill>
+                <a:latin typeface="Arial"/>
+              </a:defRPr>
+            </a:pPr>
+            <a:r>
+              <a:t>A team of autonomous AI agents collaborating to answer complex business questions.</a:t>
             </a:r>
           </a:p>
         </p:txBody>
@@ -5197,7 +5549,7 @@
 </p:sld>
 </file>
 
-<file path=ppt/slides/slide6.xml><?xml version="1.0" encoding="utf-8"?>
+<file path=ppt/slides/slide7.xml><?xml version="1.0" encoding="utf-8"?>
 <p:sld xmlns:a="http://schemas.openxmlformats.org/drawingml/2006/main" xmlns:p="http://schemas.openxmlformats.org/presentationml/2006/main" xmlns:r="http://schemas.openxmlformats.org/officeDocument/2006/relationships">
   <p:cSld>
     <p:spTree>
@@ -5281,15 +5633,15 @@
               </a:defRPr>
             </a:pPr>
             <a:r>
-              <a:t>5. Real Example: Multi-Agent Execution Flow</a:t>
+              <a:t>6. Multi-Agent Orchestration Flow</a:t>
             </a:r>
           </a:p>
           <a:p>
             <a:pPr>
               <a:spcBef>
-                <a:spcPts val="400"/>
+                <a:spcPts val="300"/>
               </a:spcBef>
-              <a:defRPr sz="1200">
+              <a:defRPr sz="1150">
                 <a:solidFill>
                   <a:srgbClr val="94A3B8"/>
                 </a:solidFill>
@@ -5297,7 +5649,230 @@
               </a:defRPr>
             </a:pPr>
             <a:r>
-              <a:t>How a user question triggers a multi-agent sequence to deliver end-to-end answers.</a:t>
+              <a:t>Autonomous intent classification, sequential agent chaining, and context forwarding.</a:t>
+            </a:r>
+          </a:p>
+        </p:txBody>
+      </p:sp>
+      <p:pic>
+        <p:nvPicPr>
+          <p:cNvPr id="4" name="Picture 3" descr="agent_flow_diagram.png"/>
+          <p:cNvPicPr>
+            <a:picLocks noChangeAspect="1"/>
+          </p:cNvPicPr>
+          <p:nvPr/>
+        </p:nvPicPr>
+        <p:blipFill>
+          <a:blip r:embed="rId2"/>
+          <a:stretch>
+            <a:fillRect/>
+          </a:stretch>
+        </p:blipFill>
+        <p:spPr>
+          <a:xfrm>
+            <a:off x="731520" y="1371600"/>
+            <a:ext cx="10728655" cy="1616797"/>
+          </a:xfrm>
+          <a:prstGeom prst="rect">
+            <a:avLst/>
+          </a:prstGeom>
+        </p:spPr>
+      </p:pic>
+      <p:sp>
+        <p:nvSpPr>
+          <p:cNvPr id="5" name="Rounded Rectangle 4"/>
+          <p:cNvSpPr/>
+          <p:nvPr/>
+        </p:nvSpPr>
+        <p:spPr>
+          <a:xfrm>
+            <a:off x="731520" y="4114800"/>
+            <a:ext cx="10728655" cy="2103120"/>
+          </a:xfrm>
+          <a:prstGeom prst="roundRect">
+            <a:avLst/>
+          </a:prstGeom>
+          <a:solidFill>
+            <a:srgbClr val="1E293B"/>
+          </a:solidFill>
+          <a:ln w="12700">
+            <a:solidFill>
+              <a:srgbClr val="475569"/>
+            </a:solidFill>
+          </a:ln>
+        </p:spPr>
+        <p:style>
+          <a:lnRef idx="1">
+            <a:schemeClr val="accent1"/>
+          </a:lnRef>
+          <a:fillRef idx="3">
+            <a:schemeClr val="accent1"/>
+          </a:fillRef>
+          <a:effectRef idx="2">
+            <a:schemeClr val="accent1"/>
+          </a:effectRef>
+          <a:fontRef idx="minor">
+            <a:schemeClr val="lt1"/>
+          </a:fontRef>
+        </p:style>
+        <p:txBody>
+          <a:bodyPr rtlCol="0" anchor="ctr" wrap="square" lIns="182880" rIns="182880" tIns="182880" bIns="182880"/>
+          <a:lstStyle/>
+          <a:p>
+            <a:pPr algn="ctr">
+              <a:spcAft>
+                <a:spcPts val="600"/>
+              </a:spcAft>
+              <a:defRPr sz="1350" b="1">
+                <a:solidFill>
+                  <a:srgbClr val="6366F1"/>
+                </a:solidFill>
+                <a:latin typeface="Arial"/>
+              </a:defRPr>
+            </a:pPr>
+            <a:r>
+              <a:t>HOW AGENTS CHAIN TOGETHER</a:t>
+            </a:r>
+          </a:p>
+          <a:p>
+            <a:pPr>
+              <a:spcBef>
+                <a:spcPts val="300"/>
+              </a:spcBef>
+              <a:defRPr sz="1000">
+                <a:solidFill>
+                  <a:srgbClr val="F8FAFC"/>
+                </a:solidFill>
+                <a:latin typeface="Arial"/>
+              </a:defRPr>
+            </a:pPr>
+            <a:r>
+              <a:t>1. User Question → Auto Router analyzes intent and selects agent sequence (e.g. ['data', 'insight', 'action']).</a:t>
+            </a:r>
+            <a:br/>
+            <a:r>
+              <a:t>2. Data Agent executes safe SQL against Gold schema → Passes query results as context to Insight Agent.</a:t>
+            </a:r>
+            <a:br/>
+            <a:r>
+              <a:t>3. Insight Agent derives evidence-backed business insights → Passes insight as context to Action Agent.</a:t>
+            </a:r>
+            <a:br/>
+            <a:r>
+              <a:t>4. Action Agent formulates specific management recommendations → Streamlit UI renders formatted response cards.</a:t>
+            </a:r>
+          </a:p>
+        </p:txBody>
+      </p:sp>
+    </p:spTree>
+  </p:cSld>
+  <p:clrMapOvr>
+    <a:masterClrMapping/>
+  </p:clrMapOvr>
+</p:sld>
+</file>
+
+<file path=ppt/slides/slide8.xml><?xml version="1.0" encoding="utf-8"?>
+<p:sld xmlns:a="http://schemas.openxmlformats.org/drawingml/2006/main" xmlns:p="http://schemas.openxmlformats.org/presentationml/2006/main" xmlns:r="http://schemas.openxmlformats.org/officeDocument/2006/relationships">
+  <p:cSld>
+    <p:spTree>
+      <p:nvGrpSpPr>
+        <p:cNvPr id="1" name=""/>
+        <p:cNvGrpSpPr/>
+        <p:nvPr/>
+      </p:nvGrpSpPr>
+      <p:grpSpPr/>
+      <p:sp>
+        <p:nvSpPr>
+          <p:cNvPr id="2" name="Rectangle 1"/>
+          <p:cNvSpPr/>
+          <p:nvPr/>
+        </p:nvSpPr>
+        <p:spPr>
+          <a:xfrm>
+            <a:off x="0" y="0"/>
+            <a:ext cx="12191695" cy="6858000"/>
+          </a:xfrm>
+          <a:prstGeom prst="rect">
+            <a:avLst/>
+          </a:prstGeom>
+          <a:solidFill>
+            <a:srgbClr val="0F172A"/>
+          </a:solidFill>
+          <a:ln>
+            <a:noFill/>
+          </a:ln>
+        </p:spPr>
+        <p:style>
+          <a:lnRef idx="1">
+            <a:schemeClr val="accent1"/>
+          </a:lnRef>
+          <a:fillRef idx="3">
+            <a:schemeClr val="accent1"/>
+          </a:fillRef>
+          <a:effectRef idx="2">
+            <a:schemeClr val="accent1"/>
+          </a:effectRef>
+          <a:fontRef idx="minor">
+            <a:schemeClr val="lt1"/>
+          </a:fontRef>
+        </p:style>
+        <p:txBody>
+          <a:bodyPr rtlCol="0" anchor="ctr"/>
+          <a:lstStyle/>
+          <a:p>
+            <a:pPr algn="ctr"/>
+          </a:p>
+        </p:txBody>
+      </p:sp>
+      <p:sp>
+        <p:nvSpPr>
+          <p:cNvPr id="3" name="TextBox 2"/>
+          <p:cNvSpPr txBox="1"/>
+          <p:nvPr/>
+        </p:nvSpPr>
+        <p:spPr>
+          <a:xfrm>
+            <a:off x="731520" y="365760"/>
+            <a:ext cx="10728655" cy="914400"/>
+          </a:xfrm>
+          <a:prstGeom prst="rect">
+            <a:avLst/>
+          </a:prstGeom>
+          <a:noFill/>
+        </p:spPr>
+        <p:txBody>
+          <a:bodyPr wrap="square" lIns="0" tIns="0" rIns="0" bIns="0">
+            <a:spAutoFit/>
+          </a:bodyPr>
+          <a:lstStyle/>
+          <a:p>
+            <a:pPr>
+              <a:defRPr sz="2400" b="1">
+                <a:solidFill>
+                  <a:srgbClr val="F8FAFC"/>
+                </a:solidFill>
+                <a:latin typeface="Arial"/>
+              </a:defRPr>
+            </a:pPr>
+            <a:r>
+              <a:t>7. Case Study: Answering a Complex Question</a:t>
+            </a:r>
+          </a:p>
+          <a:p>
+            <a:pPr>
+              <a:spcBef>
+                <a:spcPts val="300"/>
+              </a:spcBef>
+              <a:defRPr sz="1150">
+                <a:solidFill>
+                  <a:srgbClr val="94A3B8"/>
+                </a:solidFill>
+                <a:latin typeface="Arial"/>
+              </a:defRPr>
+            </a:pPr>
+            <a:r>
+              <a:t>Step-by-step execution trace when a user asks a complex multi-part question.</a:t>
             </a:r>
           </a:p>
         </p:txBody>
@@ -5344,7 +5919,7 @@
           <a:lstStyle/>
           <a:p>
             <a:pPr algn="ctr">
-              <a:defRPr sz="1050">
+              <a:defRPr sz="1000">
                 <a:solidFill>
                   <a:srgbClr val="F8FAFC"/>
                 </a:solidFill>
@@ -5400,9 +5975,9 @@
           <a:p>
             <a:pPr algn="ctr">
               <a:spcAft>
-                <a:spcPts val="800"/>
+                <a:spcPts val="600"/>
               </a:spcAft>
-              <a:defRPr sz="1400" b="1">
+              <a:defRPr sz="1350" b="1">
                 <a:solidFill>
                   <a:srgbClr val="6366F1"/>
                 </a:solidFill>
@@ -5416,9 +5991,9 @@
           <a:p>
             <a:pPr>
               <a:spcBef>
-                <a:spcPts val="400"/>
+                <a:spcPts val="300"/>
               </a:spcBef>
-              <a:defRPr sz="1050">
+              <a:defRPr sz="1000">
                 <a:solidFill>
                   <a:srgbClr val="F8FAFC"/>
                 </a:solidFill>
@@ -5474,9 +6049,9 @@
           <a:p>
             <a:pPr algn="ctr">
               <a:spcAft>
-                <a:spcPts val="800"/>
+                <a:spcPts val="600"/>
               </a:spcAft>
-              <a:defRPr sz="1400" b="1">
+              <a:defRPr sz="1350" b="1">
                 <a:solidFill>
                   <a:srgbClr val="10B981"/>
                 </a:solidFill>
@@ -5490,9 +6065,9 @@
           <a:p>
             <a:pPr>
               <a:spcBef>
-                <a:spcPts val="400"/>
+                <a:spcPts val="300"/>
               </a:spcBef>
-              <a:defRPr sz="1050">
+              <a:defRPr sz="1000">
                 <a:solidFill>
                   <a:srgbClr val="F8FAFC"/>
                 </a:solidFill>
@@ -5548,9 +6123,9 @@
           <a:p>
             <a:pPr algn="ctr">
               <a:spcAft>
-                <a:spcPts val="800"/>
+                <a:spcPts val="600"/>
               </a:spcAft>
-              <a:defRPr sz="1400" b="1">
+              <a:defRPr sz="1350" b="1">
                 <a:solidFill>
                   <a:srgbClr val="F59E0B"/>
                 </a:solidFill>
@@ -5564,9 +6139,9 @@
           <a:p>
             <a:pPr>
               <a:spcBef>
-                <a:spcPts val="400"/>
+                <a:spcPts val="300"/>
               </a:spcBef>
-              <a:defRPr sz="1050">
+              <a:defRPr sz="1000">
                 <a:solidFill>
                   <a:srgbClr val="F8FAFC"/>
                 </a:solidFill>
@@ -5622,9 +6197,9 @@
           <a:p>
             <a:pPr algn="ctr">
               <a:spcAft>
-                <a:spcPts val="800"/>
+                <a:spcPts val="600"/>
               </a:spcAft>
-              <a:defRPr sz="1400" b="1">
+              <a:defRPr sz="1350" b="1">
                 <a:solidFill>
                   <a:srgbClr val="6366F1"/>
                 </a:solidFill>
@@ -5638,9 +6213,9 @@
           <a:p>
             <a:pPr>
               <a:spcBef>
-                <a:spcPts val="400"/>
+                <a:spcPts val="300"/>
               </a:spcBef>
-              <a:defRPr sz="1050">
+              <a:defRPr sz="1000">
                 <a:solidFill>
                   <a:srgbClr val="F8FAFC"/>
                 </a:solidFill>
@@ -5661,7 +6236,7 @@
 </p:sld>
 </file>
 
-<file path=ppt/slides/slide7.xml><?xml version="1.0" encoding="utf-8"?>
+<file path=ppt/slides/slide9.xml><?xml version="1.0" encoding="utf-8"?>
 <p:sld xmlns:a="http://schemas.openxmlformats.org/drawingml/2006/main" xmlns:p="http://schemas.openxmlformats.org/presentationml/2006/main" xmlns:r="http://schemas.openxmlformats.org/officeDocument/2006/relationships">
   <p:cSld>
     <p:spTree>
@@ -5745,15 +6320,15 @@
               </a:defRPr>
             </a:pPr>
             <a:r>
-              <a:t>6. User Interface &amp; BI Dashboard Features</a:t>
+              <a:t>8. Presentation Layer &amp; UI Features</a:t>
             </a:r>
           </a:p>
           <a:p>
             <a:pPr>
               <a:spcBef>
-                <a:spcPts val="400"/>
+                <a:spcPts val="300"/>
               </a:spcBef>
-              <a:defRPr sz="1200">
+              <a:defRPr sz="1150">
                 <a:solidFill>
                   <a:srgbClr val="94A3B8"/>
                 </a:solidFill>
@@ -5809,9 +6384,9 @@
           <a:p>
             <a:pPr algn="ctr">
               <a:spcAft>
-                <a:spcPts val="800"/>
+                <a:spcPts val="600"/>
               </a:spcAft>
-              <a:defRPr sz="1400" b="1">
+              <a:defRPr sz="1350" b="1">
                 <a:solidFill>
                   <a:srgbClr val="6366F1"/>
                 </a:solidFill>
@@ -5825,9 +6400,9 @@
           <a:p>
             <a:pPr>
               <a:spcBef>
-                <a:spcPts val="400"/>
+                <a:spcPts val="300"/>
               </a:spcBef>
-              <a:defRPr sz="1050">
+              <a:defRPr sz="1000">
                 <a:solidFill>
                   <a:srgbClr val="F8FAFC"/>
                 </a:solidFill>
@@ -5903,9 +6478,9 @@
           <a:p>
             <a:pPr algn="ctr">
               <a:spcAft>
-                <a:spcPts val="800"/>
+                <a:spcPts val="600"/>
               </a:spcAft>
-              <a:defRPr sz="1400" b="1">
+              <a:defRPr sz="1350" b="1">
                 <a:solidFill>
                   <a:srgbClr val="10B981"/>
                 </a:solidFill>
@@ -5919,9 +6494,9 @@
           <a:p>
             <a:pPr>
               <a:spcBef>
-                <a:spcPts val="400"/>
+                <a:spcPts val="300"/>
               </a:spcBef>
-              <a:defRPr sz="1050">
+              <a:defRPr sz="1000">
                 <a:solidFill>
                   <a:srgbClr val="F8FAFC"/>
                 </a:solidFill>
@@ -5961,321 +6536,6 @@
             <a:br/>
             <a:r>
               <a:t>   Moving average lines, Z-score anomaly threshold graphs &amp; MoM growth breakdown.</a:t>
-            </a:r>
-          </a:p>
-        </p:txBody>
-      </p:sp>
-    </p:spTree>
-  </p:cSld>
-  <p:clrMapOvr>
-    <a:masterClrMapping/>
-  </p:clrMapOvr>
-</p:sld>
-</file>
-
-<file path=ppt/slides/slide8.xml><?xml version="1.0" encoding="utf-8"?>
-<p:sld xmlns:a="http://schemas.openxmlformats.org/drawingml/2006/main" xmlns:p="http://schemas.openxmlformats.org/presentationml/2006/main" xmlns:r="http://schemas.openxmlformats.org/officeDocument/2006/relationships">
-  <p:cSld>
-    <p:spTree>
-      <p:nvGrpSpPr>
-        <p:cNvPr id="1" name=""/>
-        <p:cNvGrpSpPr/>
-        <p:nvPr/>
-      </p:nvGrpSpPr>
-      <p:grpSpPr/>
-      <p:sp>
-        <p:nvSpPr>
-          <p:cNvPr id="2" name="Rectangle 1"/>
-          <p:cNvSpPr/>
-          <p:nvPr/>
-        </p:nvSpPr>
-        <p:spPr>
-          <a:xfrm>
-            <a:off x="0" y="0"/>
-            <a:ext cx="12191695" cy="6858000"/>
-          </a:xfrm>
-          <a:prstGeom prst="rect">
-            <a:avLst/>
-          </a:prstGeom>
-          <a:solidFill>
-            <a:srgbClr val="0F172A"/>
-          </a:solidFill>
-          <a:ln>
-            <a:noFill/>
-          </a:ln>
-        </p:spPr>
-        <p:style>
-          <a:lnRef idx="1">
-            <a:schemeClr val="accent1"/>
-          </a:lnRef>
-          <a:fillRef idx="3">
-            <a:schemeClr val="accent1"/>
-          </a:fillRef>
-          <a:effectRef idx="2">
-            <a:schemeClr val="accent1"/>
-          </a:effectRef>
-          <a:fontRef idx="minor">
-            <a:schemeClr val="lt1"/>
-          </a:fontRef>
-        </p:style>
-        <p:txBody>
-          <a:bodyPr rtlCol="0" anchor="ctr"/>
-          <a:lstStyle/>
-          <a:p>
-            <a:pPr algn="ctr"/>
-          </a:p>
-        </p:txBody>
-      </p:sp>
-      <p:sp>
-        <p:nvSpPr>
-          <p:cNvPr id="3" name="TextBox 2"/>
-          <p:cNvSpPr txBox="1"/>
-          <p:nvPr/>
-        </p:nvSpPr>
-        <p:spPr>
-          <a:xfrm>
-            <a:off x="731520" y="365760"/>
-            <a:ext cx="10728655" cy="914400"/>
-          </a:xfrm>
-          <a:prstGeom prst="rect">
-            <a:avLst/>
-          </a:prstGeom>
-          <a:noFill/>
-        </p:spPr>
-        <p:txBody>
-          <a:bodyPr wrap="square" lIns="0" tIns="0" rIns="0" bIns="0">
-            <a:spAutoFit/>
-          </a:bodyPr>
-          <a:lstStyle/>
-          <a:p>
-            <a:pPr>
-              <a:defRPr sz="2400" b="1">
-                <a:solidFill>
-                  <a:srgbClr val="F8FAFC"/>
-                </a:solidFill>
-                <a:latin typeface="Arial"/>
-              </a:defRPr>
-            </a:pPr>
-            <a:r>
-              <a:t>7. Project Evaluation Summary &amp; Live Demo</a:t>
-            </a:r>
-          </a:p>
-          <a:p>
-            <a:pPr>
-              <a:spcBef>
-                <a:spcPts val="400"/>
-              </a:spcBef>
-              <a:defRPr sz="1200">
-                <a:solidFill>
-                  <a:srgbClr val="94A3B8"/>
-                </a:solidFill>
-                <a:latin typeface="Arial"/>
-              </a:defRPr>
-            </a:pPr>
-            <a:r>
-              <a:t>100% operational, fully verified, and ready for live presentation.</a:t>
-            </a:r>
-          </a:p>
-        </p:txBody>
-      </p:sp>
-      <p:sp>
-        <p:nvSpPr>
-          <p:cNvPr id="4" name="Rounded Rectangle 3"/>
-          <p:cNvSpPr/>
-          <p:nvPr/>
-        </p:nvSpPr>
-        <p:spPr>
-          <a:xfrm>
-            <a:off x="731520" y="1463040"/>
-            <a:ext cx="5120640" cy="4754880"/>
-          </a:xfrm>
-          <a:prstGeom prst="roundRect">
-            <a:avLst/>
-          </a:prstGeom>
-          <a:solidFill>
-            <a:srgbClr val="1E293B"/>
-          </a:solidFill>
-          <a:ln w="12700">
-            <a:solidFill>
-              <a:srgbClr val="475569"/>
-            </a:solidFill>
-          </a:ln>
-        </p:spPr>
-        <p:style>
-          <a:lnRef idx="1">
-            <a:schemeClr val="accent1"/>
-          </a:lnRef>
-          <a:fillRef idx="3">
-            <a:schemeClr val="accent1"/>
-          </a:fillRef>
-          <a:effectRef idx="2">
-            <a:schemeClr val="accent1"/>
-          </a:effectRef>
-          <a:fontRef idx="minor">
-            <a:schemeClr val="lt1"/>
-          </a:fontRef>
-        </p:style>
-        <p:txBody>
-          <a:bodyPr rtlCol="0" anchor="ctr" wrap="square" lIns="182880" rIns="182880" tIns="182880" bIns="182880"/>
-          <a:lstStyle/>
-          <a:p>
-            <a:pPr algn="ctr">
-              <a:spcAft>
-                <a:spcPts val="800"/>
-              </a:spcAft>
-              <a:defRPr sz="1400" b="1">
-                <a:solidFill>
-                  <a:srgbClr val="10B981"/>
-                </a:solidFill>
-                <a:latin typeface="Arial"/>
-              </a:defRPr>
-            </a:pPr>
-            <a:r>
-              <a:t>⭐ KEY PROJECT HIGHLIGHTS</a:t>
-            </a:r>
-          </a:p>
-          <a:p>
-            <a:pPr>
-              <a:spcBef>
-                <a:spcPts val="400"/>
-              </a:spcBef>
-              <a:defRPr sz="1050">
-                <a:solidFill>
-                  <a:srgbClr val="F8FAFC"/>
-                </a:solidFill>
-                <a:latin typeface="Arial"/>
-              </a:defRPr>
-            </a:pPr>
-            <a:r>
-              <a:t>• End-to-End Pipeline: Raw data ingested, cleansed in Silver, and modeled into Gold Star Schema (3,938 records).</a:t>
-            </a:r>
-            <a:br/>
-            <a:r>
-              <a:t>• Historical Accuracy: Fully supports SCD Type 1 &amp; Type 2 location history.</a:t>
-            </a:r>
-            <a:br/>
-            <a:r>
-              <a:t>• Robust Data Quality: Great Expectations rules &amp; execution tracking.</a:t>
-            </a:r>
-            <a:br/>
-            <a:r>
-              <a:t>• Autonomous Multi-Agent AI: 9 specialized AI agents collaborating.</a:t>
-            </a:r>
-            <a:br/>
-            <a:r>
-              <a:t>• SQL Security: Enforces strict read-only query validator (blocks DROP, DELETE, etc.).</a:t>
-            </a:r>
-            <a:br/>
-            <a:r>
-              <a:t>• Rate-Limit Protection: Fast pattern fallbacks ensure instant answers (&lt; 1 second).</a:t>
-            </a:r>
-          </a:p>
-        </p:txBody>
-      </p:sp>
-      <p:sp>
-        <p:nvSpPr>
-          <p:cNvPr id="5" name="Rounded Rectangle 4"/>
-          <p:cNvSpPr/>
-          <p:nvPr/>
-        </p:nvSpPr>
-        <p:spPr>
-          <a:xfrm>
-            <a:off x="6217920" y="1463040"/>
-            <a:ext cx="5212080" cy="4754880"/>
-          </a:xfrm>
-          <a:prstGeom prst="roundRect">
-            <a:avLst/>
-          </a:prstGeom>
-          <a:solidFill>
-            <a:srgbClr val="1E293B"/>
-          </a:solidFill>
-          <a:ln w="12700">
-            <a:solidFill>
-              <a:srgbClr val="475569"/>
-            </a:solidFill>
-          </a:ln>
-        </p:spPr>
-        <p:style>
-          <a:lnRef idx="1">
-            <a:schemeClr val="accent1"/>
-          </a:lnRef>
-          <a:fillRef idx="3">
-            <a:schemeClr val="accent1"/>
-          </a:fillRef>
-          <a:effectRef idx="2">
-            <a:schemeClr val="accent1"/>
-          </a:effectRef>
-          <a:fontRef idx="minor">
-            <a:schemeClr val="lt1"/>
-          </a:fontRef>
-        </p:style>
-        <p:txBody>
-          <a:bodyPr rtlCol="0" anchor="ctr" wrap="square" lIns="182880" rIns="182880" tIns="182880" bIns="182880"/>
-          <a:lstStyle/>
-          <a:p>
-            <a:pPr algn="ctr">
-              <a:spcAft>
-                <a:spcPts val="800"/>
-              </a:spcAft>
-              <a:defRPr sz="1400" b="1">
-                <a:solidFill>
-                  <a:srgbClr val="6366F1"/>
-                </a:solidFill>
-                <a:latin typeface="Arial"/>
-              </a:defRPr>
-            </a:pPr>
-            <a:r>
-              <a:t>🚀 LIVE EVALUATION DEMO URLS</a:t>
-            </a:r>
-          </a:p>
-          <a:p>
-            <a:pPr>
-              <a:spcBef>
-                <a:spcPts val="400"/>
-              </a:spcBef>
-              <a:defRPr sz="1050">
-                <a:solidFill>
-                  <a:srgbClr val="F8FAFC"/>
-                </a:solidFill>
-                <a:latin typeface="Arial"/>
-              </a:defRPr>
-            </a:pPr>
-            <a:r>
-              <a:t>1. Streamlit Application &amp; AI Chatbot:</a:t>
-            </a:r>
-            <a:br/>
-            <a:r>
-              <a:t>   URL:  http://localhost:8501</a:t>
-            </a:r>
-            <a:br/>
-            <a:r>
-              <a:t>   Status:  100% Connected &amp; Ready (All Badges Green 🟢)</a:t>
-            </a:r>
-            <a:br/>
-            <a:br/>
-            <a:r>
-              <a:t>2. Apache Airflow Pipeline Orchestration:</a:t>
-            </a:r>
-            <a:br/>
-            <a:r>
-              <a:t>   URL:  http://localhost:8080</a:t>
-            </a:r>
-            <a:br/>
-            <a:r>
-              <a:t>   User: admin  /  Password: admin123</a:t>
-            </a:r>
-            <a:br/>
-            <a:r>
-              <a:t>   DAGs: 01_bronze_ingestion, 02_silver_transform, 03_gold_aggregation</a:t>
-            </a:r>
-            <a:br/>
-            <a:br/>
-            <a:r>
-              <a:t>3. Comprehensive PDF Report Generated:</a:t>
-            </a:r>
-            <a:br/>
-            <a:r>
-              <a:t>   File: Data_Engineering_Agentic_AI_Final_Report.pdf</a:t>
             </a:r>
           </a:p>
         </p:txBody>

</xml_diff>

<commit_message>
Update presentation slides with native vector architecture shapes and clear process flow
</commit_message>
<xml_diff>
--- a/ECommerce_Agentic_AI_Presentation.pptx
+++ b/ECommerce_Agentic_AI_Presentation.pptx
@@ -3988,40 +3988,16 @@
           </a:p>
         </p:txBody>
       </p:sp>
-      <p:pic>
-        <p:nvPicPr>
-          <p:cNvPr id="4" name="Picture 3" descr="medallion_diagram.png"/>
-          <p:cNvPicPr>
-            <a:picLocks noChangeAspect="1"/>
-          </p:cNvPicPr>
+      <p:sp>
+        <p:nvSpPr>
+          <p:cNvPr id="4" name="Rounded Rectangle 3"/>
+          <p:cNvSpPr/>
           <p:nvPr/>
-        </p:nvPicPr>
-        <p:blipFill>
-          <a:blip r:embed="rId2"/>
-          <a:stretch>
-            <a:fillRect/>
-          </a:stretch>
-        </p:blipFill>
+        </p:nvSpPr>
         <p:spPr>
           <a:xfrm>
-            <a:off x="731520" y="1371600"/>
-            <a:ext cx="10728655" cy="1220940"/>
-          </a:xfrm>
-          <a:prstGeom prst="rect">
-            <a:avLst/>
-          </a:prstGeom>
-        </p:spPr>
-      </p:pic>
-      <p:sp>
-        <p:nvSpPr>
-          <p:cNvPr id="5" name="Rounded Rectangle 4"/>
-          <p:cNvSpPr/>
-          <p:nvPr/>
-        </p:nvSpPr>
-        <p:spPr>
-          <a:xfrm>
-            <a:off x="731520" y="4114800"/>
-            <a:ext cx="10728655" cy="2103120"/>
+            <a:off x="731520" y="1463040"/>
+            <a:ext cx="2377440" cy="2011680"/>
           </a:xfrm>
           <a:prstGeom prst="roundRect">
             <a:avLst/>
@@ -4059,13 +4035,13 @@
               </a:spcAft>
               <a:defRPr sz="1350" b="1">
                 <a:solidFill>
-                  <a:srgbClr val="6366F1"/>
+                  <a:srgbClr val="475569"/>
                 </a:solidFill>
                 <a:latin typeface="Arial"/>
               </a:defRPr>
             </a:pPr>
             <a:r>
-              <a:t>MEDALLION PIPELINE BREAKDOWN</a:t>
+              <a:t>1. RAW SOURCES</a:t>
             </a:r>
           </a:p>
           <a:p>
@@ -4081,15 +4057,453 @@
               </a:defRPr>
             </a:pPr>
             <a:r>
-              <a:t>• Bronze Layer (🟫 Raw): Append-only storage for original customer order feeds. Preserves raw state with batch IDs and timestamps.</a:t>
-            </a:r>
-            <a:br/>
-            <a:r>
-              <a:t>• Silver Layer (🥈 Cleansed): Standardizes date formats, cleans currencies, removes duplicates, translates categories to English, and tracks SCD Type 2.</a:t>
-            </a:r>
-            <a:br/>
-            <a:r>
-              <a:t>• Gold Layer (🥇 Analytics Star Schema): Optimized dimensional star schema (fact_sales, dim_customer, dim_product, dim_seller, dim_date, revenue_mart).</a:t>
+              <a:t>CSV, JSON, APIs</a:t>
+            </a:r>
+            <a:br/>
+            <a:r>
+              <a:t>Orders, Customers,</a:t>
+            </a:r>
+            <a:br/>
+            <a:r>
+              <a:t>Sellers &amp; Products</a:t>
+            </a:r>
+          </a:p>
+        </p:txBody>
+      </p:sp>
+      <p:sp>
+        <p:nvSpPr>
+          <p:cNvPr id="5" name="TextBox 4"/>
+          <p:cNvSpPr txBox="1"/>
+          <p:nvPr/>
+        </p:nvSpPr>
+        <p:spPr>
+          <a:xfrm>
+            <a:off x="3108960" y="2194560"/>
+            <a:ext cx="402336" cy="548640"/>
+          </a:xfrm>
+          <a:prstGeom prst="rect">
+            <a:avLst/>
+          </a:prstGeom>
+          <a:noFill/>
+        </p:spPr>
+        <p:txBody>
+          <a:bodyPr wrap="none">
+            <a:spAutoFit/>
+          </a:bodyPr>
+          <a:lstStyle/>
+          <a:p>
+            <a:pPr algn="ctr">
+              <a:defRPr sz="2000" b="1">
+                <a:solidFill>
+                  <a:srgbClr val="6366F1"/>
+                </a:solidFill>
+                <a:latin typeface="Arial"/>
+              </a:defRPr>
+            </a:pPr>
+            <a:r>
+              <a:t>➔</a:t>
+            </a:r>
+          </a:p>
+        </p:txBody>
+      </p:sp>
+      <p:sp>
+        <p:nvSpPr>
+          <p:cNvPr id="6" name="Rounded Rectangle 5"/>
+          <p:cNvSpPr/>
+          <p:nvPr/>
+        </p:nvSpPr>
+        <p:spPr>
+          <a:xfrm>
+            <a:off x="3511296" y="1463040"/>
+            <a:ext cx="2377440" cy="2011680"/>
+          </a:xfrm>
+          <a:prstGeom prst="roundRect">
+            <a:avLst/>
+          </a:prstGeom>
+          <a:solidFill>
+            <a:srgbClr val="1E293B"/>
+          </a:solidFill>
+          <a:ln w="12700">
+            <a:solidFill>
+              <a:srgbClr val="D97706"/>
+            </a:solidFill>
+          </a:ln>
+        </p:spPr>
+        <p:style>
+          <a:lnRef idx="1">
+            <a:schemeClr val="accent1"/>
+          </a:lnRef>
+          <a:fillRef idx="3">
+            <a:schemeClr val="accent1"/>
+          </a:fillRef>
+          <a:effectRef idx="2">
+            <a:schemeClr val="accent1"/>
+          </a:effectRef>
+          <a:fontRef idx="minor">
+            <a:schemeClr val="lt1"/>
+          </a:fontRef>
+        </p:style>
+        <p:txBody>
+          <a:bodyPr rtlCol="0" anchor="ctr" wrap="square" lIns="182880" rIns="182880" tIns="182880" bIns="182880"/>
+          <a:lstStyle/>
+          <a:p>
+            <a:pPr algn="ctr">
+              <a:spcAft>
+                <a:spcPts val="600"/>
+              </a:spcAft>
+              <a:defRPr sz="1350" b="1">
+                <a:solidFill>
+                  <a:srgbClr val="D97706"/>
+                </a:solidFill>
+                <a:latin typeface="Arial"/>
+              </a:defRPr>
+            </a:pPr>
+            <a:r>
+              <a:t>2. BRONZE LAYER</a:t>
+            </a:r>
+          </a:p>
+          <a:p>
+            <a:pPr>
+              <a:spcBef>
+                <a:spcPts val="300"/>
+              </a:spcBef>
+              <a:defRPr sz="1000">
+                <a:solidFill>
+                  <a:srgbClr val="F8FAFC"/>
+                </a:solidFill>
+                <a:latin typeface="Arial"/>
+              </a:defRPr>
+            </a:pPr>
+            <a:r>
+              <a:t>Raw Storage 🟫</a:t>
+            </a:r>
+            <a:br/>
+            <a:r>
+              <a:t>Append-Only Ingestion</a:t>
+            </a:r>
+            <a:br/>
+            <a:r>
+              <a:t>Batch Run Auditing</a:t>
+            </a:r>
+          </a:p>
+        </p:txBody>
+      </p:sp>
+      <p:sp>
+        <p:nvSpPr>
+          <p:cNvPr id="7" name="TextBox 6"/>
+          <p:cNvSpPr txBox="1"/>
+          <p:nvPr/>
+        </p:nvSpPr>
+        <p:spPr>
+          <a:xfrm>
+            <a:off x="5888736" y="2194560"/>
+            <a:ext cx="402336" cy="548640"/>
+          </a:xfrm>
+          <a:prstGeom prst="rect">
+            <a:avLst/>
+          </a:prstGeom>
+          <a:noFill/>
+        </p:spPr>
+        <p:txBody>
+          <a:bodyPr wrap="none">
+            <a:spAutoFit/>
+          </a:bodyPr>
+          <a:lstStyle/>
+          <a:p>
+            <a:pPr algn="ctr">
+              <a:defRPr sz="2000" b="1">
+                <a:solidFill>
+                  <a:srgbClr val="6366F1"/>
+                </a:solidFill>
+                <a:latin typeface="Arial"/>
+              </a:defRPr>
+            </a:pPr>
+            <a:r>
+              <a:t>➔</a:t>
+            </a:r>
+          </a:p>
+        </p:txBody>
+      </p:sp>
+      <p:sp>
+        <p:nvSpPr>
+          <p:cNvPr id="8" name="Rounded Rectangle 7"/>
+          <p:cNvSpPr/>
+          <p:nvPr/>
+        </p:nvSpPr>
+        <p:spPr>
+          <a:xfrm>
+            <a:off x="6291072" y="1463040"/>
+            <a:ext cx="2377440" cy="2011680"/>
+          </a:xfrm>
+          <a:prstGeom prst="roundRect">
+            <a:avLst/>
+          </a:prstGeom>
+          <a:solidFill>
+            <a:srgbClr val="1E293B"/>
+          </a:solidFill>
+          <a:ln w="12700">
+            <a:solidFill>
+              <a:srgbClr val="475569"/>
+            </a:solidFill>
+          </a:ln>
+        </p:spPr>
+        <p:style>
+          <a:lnRef idx="1">
+            <a:schemeClr val="accent1"/>
+          </a:lnRef>
+          <a:fillRef idx="3">
+            <a:schemeClr val="accent1"/>
+          </a:fillRef>
+          <a:effectRef idx="2">
+            <a:schemeClr val="accent1"/>
+          </a:effectRef>
+          <a:fontRef idx="minor">
+            <a:schemeClr val="lt1"/>
+          </a:fontRef>
+        </p:style>
+        <p:txBody>
+          <a:bodyPr rtlCol="0" anchor="ctr" wrap="square" lIns="182880" rIns="182880" tIns="182880" bIns="182880"/>
+          <a:lstStyle/>
+          <a:p>
+            <a:pPr algn="ctr">
+              <a:spcAft>
+                <a:spcPts val="600"/>
+              </a:spcAft>
+              <a:defRPr sz="1350" b="1">
+                <a:solidFill>
+                  <a:srgbClr val="475569"/>
+                </a:solidFill>
+                <a:latin typeface="Arial"/>
+              </a:defRPr>
+            </a:pPr>
+            <a:r>
+              <a:t>3. SILVER LAYER</a:t>
+            </a:r>
+          </a:p>
+          <a:p>
+            <a:pPr>
+              <a:spcBef>
+                <a:spcPts val="300"/>
+              </a:spcBef>
+              <a:defRPr sz="1000">
+                <a:solidFill>
+                  <a:srgbClr val="F8FAFC"/>
+                </a:solidFill>
+                <a:latin typeface="Arial"/>
+              </a:defRPr>
+            </a:pPr>
+            <a:r>
+              <a:t>Cleaned &amp; Standard 🥈</a:t>
+            </a:r>
+            <a:br/>
+            <a:r>
+              <a:t>ISO Dates, Currency Cast</a:t>
+            </a:r>
+            <a:br/>
+            <a:r>
+              <a:t>SCD Type 2 History</a:t>
+            </a:r>
+          </a:p>
+        </p:txBody>
+      </p:sp>
+      <p:sp>
+        <p:nvSpPr>
+          <p:cNvPr id="9" name="TextBox 8"/>
+          <p:cNvSpPr txBox="1"/>
+          <p:nvPr/>
+        </p:nvSpPr>
+        <p:spPr>
+          <a:xfrm>
+            <a:off x="8668512" y="2194560"/>
+            <a:ext cx="402336" cy="548640"/>
+          </a:xfrm>
+          <a:prstGeom prst="rect">
+            <a:avLst/>
+          </a:prstGeom>
+          <a:noFill/>
+        </p:spPr>
+        <p:txBody>
+          <a:bodyPr wrap="none">
+            <a:spAutoFit/>
+          </a:bodyPr>
+          <a:lstStyle/>
+          <a:p>
+            <a:pPr algn="ctr">
+              <a:defRPr sz="2000" b="1">
+                <a:solidFill>
+                  <a:srgbClr val="6366F1"/>
+                </a:solidFill>
+                <a:latin typeface="Arial"/>
+              </a:defRPr>
+            </a:pPr>
+            <a:r>
+              <a:t>➔</a:t>
+            </a:r>
+          </a:p>
+        </p:txBody>
+      </p:sp>
+      <p:sp>
+        <p:nvSpPr>
+          <p:cNvPr id="10" name="Rounded Rectangle 9"/>
+          <p:cNvSpPr/>
+          <p:nvPr/>
+        </p:nvSpPr>
+        <p:spPr>
+          <a:xfrm>
+            <a:off x="9070848" y="1463040"/>
+            <a:ext cx="2377440" cy="2011680"/>
+          </a:xfrm>
+          <a:prstGeom prst="roundRect">
+            <a:avLst/>
+          </a:prstGeom>
+          <a:solidFill>
+            <a:srgbClr val="1E293B"/>
+          </a:solidFill>
+          <a:ln w="12700">
+            <a:solidFill>
+              <a:srgbClr val="EAB308"/>
+            </a:solidFill>
+          </a:ln>
+        </p:spPr>
+        <p:style>
+          <a:lnRef idx="1">
+            <a:schemeClr val="accent1"/>
+          </a:lnRef>
+          <a:fillRef idx="3">
+            <a:schemeClr val="accent1"/>
+          </a:fillRef>
+          <a:effectRef idx="2">
+            <a:schemeClr val="accent1"/>
+          </a:effectRef>
+          <a:fontRef idx="minor">
+            <a:schemeClr val="lt1"/>
+          </a:fontRef>
+        </p:style>
+        <p:txBody>
+          <a:bodyPr rtlCol="0" anchor="ctr" wrap="square" lIns="182880" rIns="182880" tIns="182880" bIns="182880"/>
+          <a:lstStyle/>
+          <a:p>
+            <a:pPr algn="ctr">
+              <a:spcAft>
+                <a:spcPts val="600"/>
+              </a:spcAft>
+              <a:defRPr sz="1350" b="1">
+                <a:solidFill>
+                  <a:srgbClr val="EAB308"/>
+                </a:solidFill>
+                <a:latin typeface="Arial"/>
+              </a:defRPr>
+            </a:pPr>
+            <a:r>
+              <a:t>4. GOLD LAYER</a:t>
+            </a:r>
+          </a:p>
+          <a:p>
+            <a:pPr>
+              <a:spcBef>
+                <a:spcPts val="300"/>
+              </a:spcBef>
+              <a:defRPr sz="1000">
+                <a:solidFill>
+                  <a:srgbClr val="F8FAFC"/>
+                </a:solidFill>
+                <a:latin typeface="Arial"/>
+              </a:defRPr>
+            </a:pPr>
+            <a:r>
+              <a:t>Star Schema 🥇</a:t>
+            </a:r>
+            <a:br/>
+            <a:r>
+              <a:t>Fact &amp; Dimension Tables</a:t>
+            </a:r>
+            <a:br/>
+            <a:r>
+              <a:t>Revenue Marts</a:t>
+            </a:r>
+          </a:p>
+        </p:txBody>
+      </p:sp>
+      <p:sp>
+        <p:nvSpPr>
+          <p:cNvPr id="11" name="Rounded Rectangle 10"/>
+          <p:cNvSpPr/>
+          <p:nvPr/>
+        </p:nvSpPr>
+        <p:spPr>
+          <a:xfrm>
+            <a:off x="731520" y="3840480"/>
+            <a:ext cx="10728655" cy="2377440"/>
+          </a:xfrm>
+          <a:prstGeom prst="roundRect">
+            <a:avLst/>
+          </a:prstGeom>
+          <a:solidFill>
+            <a:srgbClr val="1E293B"/>
+          </a:solidFill>
+          <a:ln w="12700">
+            <a:solidFill>
+              <a:srgbClr val="475569"/>
+            </a:solidFill>
+          </a:ln>
+        </p:spPr>
+        <p:style>
+          <a:lnRef idx="1">
+            <a:schemeClr val="accent1"/>
+          </a:lnRef>
+          <a:fillRef idx="3">
+            <a:schemeClr val="accent1"/>
+          </a:fillRef>
+          <a:effectRef idx="2">
+            <a:schemeClr val="accent1"/>
+          </a:effectRef>
+          <a:fontRef idx="minor">
+            <a:schemeClr val="lt1"/>
+          </a:fontRef>
+        </p:style>
+        <p:txBody>
+          <a:bodyPr rtlCol="0" anchor="ctr" wrap="square" lIns="182880" rIns="182880" tIns="182880" bIns="182880"/>
+          <a:lstStyle/>
+          <a:p>
+            <a:pPr algn="ctr">
+              <a:spcAft>
+                <a:spcPts val="600"/>
+              </a:spcAft>
+              <a:defRPr sz="1350" b="1">
+                <a:solidFill>
+                  <a:srgbClr val="6366F1"/>
+                </a:solidFill>
+                <a:latin typeface="Arial"/>
+              </a:defRPr>
+            </a:pPr>
+            <a:r>
+              <a:t>MEDALLION PIPELINE BREAKDOWN &amp; RESPONSIBILITIES</a:t>
+            </a:r>
+          </a:p>
+          <a:p>
+            <a:pPr>
+              <a:spcBef>
+                <a:spcPts val="300"/>
+              </a:spcBef>
+              <a:defRPr sz="1000">
+                <a:solidFill>
+                  <a:srgbClr val="F8FAFC"/>
+                </a:solidFill>
+                <a:latin typeface="Arial"/>
+              </a:defRPr>
+            </a:pPr>
+            <a:r>
+              <a:t>• Bronze Layer (🟫 Raw Feeds): Stores raw incoming customer and seller transaction feeds without modification. Tracks ingestion batch IDs &amp; load timestamps.</a:t>
+            </a:r>
+            <a:br/>
+            <a:br/>
+            <a:r>
+              <a:t>• Silver Layer (🥈 Cleaned &amp; Standardized): Fixes invalid date formats, converts currency strings into NUMERIC types, eliminates duplicate rows, translates category names into English, and maintains historical SCD Type 2 tracking for customer/seller locations.</a:t>
+            </a:r>
+            <a:br/>
+            <a:br/>
+            <a:r>
+              <a:t>• Gold Layer (🥇 Analytics Star Schema): Fully optimized dimensional Star Schema (gold.fact_sales, gold.dim_customer, gold.dim_product, gold.dim_seller, gold.dim_date, gold.revenue_mart) designed for instant OLAP business queries.</a:t>
             </a:r>
           </a:p>
         </p:txBody>
@@ -5654,40 +6068,530 @@
           </a:p>
         </p:txBody>
       </p:sp>
-      <p:pic>
-        <p:nvPicPr>
-          <p:cNvPr id="4" name="Picture 3" descr="agent_flow_diagram.png"/>
-          <p:cNvPicPr>
-            <a:picLocks noChangeAspect="1"/>
-          </p:cNvPicPr>
+      <p:sp>
+        <p:nvSpPr>
+          <p:cNvPr id="4" name="Rounded Rectangle 3"/>
+          <p:cNvSpPr/>
           <p:nvPr/>
-        </p:nvPicPr>
-        <p:blipFill>
-          <a:blip r:embed="rId2"/>
-          <a:stretch>
-            <a:fillRect/>
-          </a:stretch>
-        </p:blipFill>
+        </p:nvSpPr>
         <p:spPr>
           <a:xfrm>
-            <a:off x="731520" y="1371600"/>
-            <a:ext cx="10728655" cy="1616797"/>
+            <a:off x="731520" y="1463040"/>
+            <a:ext cx="1828800" cy="2011680"/>
+          </a:xfrm>
+          <a:prstGeom prst="roundRect">
+            <a:avLst/>
+          </a:prstGeom>
+          <a:solidFill>
+            <a:srgbClr val="1E293B"/>
+          </a:solidFill>
+          <a:ln w="12700">
+            <a:solidFill>
+              <a:srgbClr val="0284C7"/>
+            </a:solidFill>
+          </a:ln>
+        </p:spPr>
+        <p:style>
+          <a:lnRef idx="1">
+            <a:schemeClr val="accent1"/>
+          </a:lnRef>
+          <a:fillRef idx="3">
+            <a:schemeClr val="accent1"/>
+          </a:fillRef>
+          <a:effectRef idx="2">
+            <a:schemeClr val="accent1"/>
+          </a:effectRef>
+          <a:fontRef idx="minor">
+            <a:schemeClr val="lt1"/>
+          </a:fontRef>
+        </p:style>
+        <p:txBody>
+          <a:bodyPr rtlCol="0" anchor="ctr" wrap="square" lIns="182880" rIns="182880" tIns="182880" bIns="182880"/>
+          <a:lstStyle/>
+          <a:p>
+            <a:pPr algn="ctr">
+              <a:spcAft>
+                <a:spcPts val="600"/>
+              </a:spcAft>
+              <a:defRPr sz="1350" b="1">
+                <a:solidFill>
+                  <a:srgbClr val="0284C7"/>
+                </a:solidFill>
+                <a:latin typeface="Arial"/>
+              </a:defRPr>
+            </a:pPr>
+            <a:r>
+              <a:t>1. USER QUESTION</a:t>
+            </a:r>
+          </a:p>
+          <a:p>
+            <a:pPr>
+              <a:spcBef>
+                <a:spcPts val="300"/>
+              </a:spcBef>
+              <a:defRPr sz="1000">
+                <a:solidFill>
+                  <a:srgbClr val="F8FAFC"/>
+                </a:solidFill>
+                <a:latin typeface="Arial"/>
+              </a:defRPr>
+            </a:pPr>
+            <a:r>
+              <a:t>Asks: 'Why did profit drop?'</a:t>
+            </a:r>
+          </a:p>
+        </p:txBody>
+      </p:sp>
+      <p:sp>
+        <p:nvSpPr>
+          <p:cNvPr id="5" name="TextBox 4"/>
+          <p:cNvSpPr txBox="1"/>
+          <p:nvPr/>
+        </p:nvSpPr>
+        <p:spPr>
+          <a:xfrm>
+            <a:off x="2560320" y="2194560"/>
+            <a:ext cx="393192" cy="548640"/>
           </a:xfrm>
           <a:prstGeom prst="rect">
             <a:avLst/>
           </a:prstGeom>
+          <a:noFill/>
         </p:spPr>
-      </p:pic>
-      <p:sp>
-        <p:nvSpPr>
-          <p:cNvPr id="5" name="Rounded Rectangle 4"/>
+        <p:txBody>
+          <a:bodyPr wrap="none">
+            <a:spAutoFit/>
+          </a:bodyPr>
+          <a:lstStyle/>
+          <a:p>
+            <a:pPr algn="ctr">
+              <a:defRPr sz="1800" b="1">
+                <a:solidFill>
+                  <a:srgbClr val="6366F1"/>
+                </a:solidFill>
+                <a:latin typeface="Arial"/>
+              </a:defRPr>
+            </a:pPr>
+            <a:r>
+              <a:t>➔</a:t>
+            </a:r>
+          </a:p>
+        </p:txBody>
+      </p:sp>
+      <p:sp>
+        <p:nvSpPr>
+          <p:cNvPr id="6" name="Rounded Rectangle 5"/>
           <p:cNvSpPr/>
           <p:nvPr/>
         </p:nvSpPr>
         <p:spPr>
           <a:xfrm>
-            <a:off x="731520" y="4114800"/>
-            <a:ext cx="10728655" cy="2103120"/>
+            <a:off x="2953512" y="1463040"/>
+            <a:ext cx="1828800" cy="2011680"/>
+          </a:xfrm>
+          <a:prstGeom prst="roundRect">
+            <a:avLst/>
+          </a:prstGeom>
+          <a:solidFill>
+            <a:srgbClr val="1E293B"/>
+          </a:solidFill>
+          <a:ln w="12700">
+            <a:solidFill>
+              <a:srgbClr val="6366F1"/>
+            </a:solidFill>
+          </a:ln>
+        </p:spPr>
+        <p:style>
+          <a:lnRef idx="1">
+            <a:schemeClr val="accent1"/>
+          </a:lnRef>
+          <a:fillRef idx="3">
+            <a:schemeClr val="accent1"/>
+          </a:fillRef>
+          <a:effectRef idx="2">
+            <a:schemeClr val="accent1"/>
+          </a:effectRef>
+          <a:fontRef idx="minor">
+            <a:schemeClr val="lt1"/>
+          </a:fontRef>
+        </p:style>
+        <p:txBody>
+          <a:bodyPr rtlCol="0" anchor="ctr" wrap="square" lIns="182880" rIns="182880" tIns="182880" bIns="182880"/>
+          <a:lstStyle/>
+          <a:p>
+            <a:pPr algn="ctr">
+              <a:spcAft>
+                <a:spcPts val="600"/>
+              </a:spcAft>
+              <a:defRPr sz="1350" b="1">
+                <a:solidFill>
+                  <a:srgbClr val="6366F1"/>
+                </a:solidFill>
+                <a:latin typeface="Arial"/>
+              </a:defRPr>
+            </a:pPr>
+            <a:r>
+              <a:t>2. AUTO ROUTER 🤖</a:t>
+            </a:r>
+          </a:p>
+          <a:p>
+            <a:pPr>
+              <a:spcBef>
+                <a:spcPts val="300"/>
+              </a:spcBef>
+              <a:defRPr sz="1000">
+                <a:solidFill>
+                  <a:srgbClr val="F8FAFC"/>
+                </a:solidFill>
+                <a:latin typeface="Arial"/>
+              </a:defRPr>
+            </a:pPr>
+            <a:r>
+              <a:t>Routes to Data+Insight+Action</a:t>
+            </a:r>
+          </a:p>
+        </p:txBody>
+      </p:sp>
+      <p:sp>
+        <p:nvSpPr>
+          <p:cNvPr id="7" name="TextBox 6"/>
+          <p:cNvSpPr txBox="1"/>
+          <p:nvPr/>
+        </p:nvSpPr>
+        <p:spPr>
+          <a:xfrm>
+            <a:off x="4782312" y="2194560"/>
+            <a:ext cx="393192" cy="548640"/>
+          </a:xfrm>
+          <a:prstGeom prst="rect">
+            <a:avLst/>
+          </a:prstGeom>
+          <a:noFill/>
+        </p:spPr>
+        <p:txBody>
+          <a:bodyPr wrap="none">
+            <a:spAutoFit/>
+          </a:bodyPr>
+          <a:lstStyle/>
+          <a:p>
+            <a:pPr algn="ctr">
+              <a:defRPr sz="1800" b="1">
+                <a:solidFill>
+                  <a:srgbClr val="6366F1"/>
+                </a:solidFill>
+                <a:latin typeface="Arial"/>
+              </a:defRPr>
+            </a:pPr>
+            <a:r>
+              <a:t>➔</a:t>
+            </a:r>
+          </a:p>
+        </p:txBody>
+      </p:sp>
+      <p:sp>
+        <p:nvSpPr>
+          <p:cNvPr id="8" name="Rounded Rectangle 7"/>
+          <p:cNvSpPr/>
+          <p:nvPr/>
+        </p:nvSpPr>
+        <p:spPr>
+          <a:xfrm>
+            <a:off x="5175504" y="1463040"/>
+            <a:ext cx="1828800" cy="2011680"/>
+          </a:xfrm>
+          <a:prstGeom prst="roundRect">
+            <a:avLst/>
+          </a:prstGeom>
+          <a:solidFill>
+            <a:srgbClr val="1E293B"/>
+          </a:solidFill>
+          <a:ln w="12700">
+            <a:solidFill>
+              <a:srgbClr val="10B981"/>
+            </a:solidFill>
+          </a:ln>
+        </p:spPr>
+        <p:style>
+          <a:lnRef idx="1">
+            <a:schemeClr val="accent1"/>
+          </a:lnRef>
+          <a:fillRef idx="3">
+            <a:schemeClr val="accent1"/>
+          </a:fillRef>
+          <a:effectRef idx="2">
+            <a:schemeClr val="accent1"/>
+          </a:effectRef>
+          <a:fontRef idx="minor">
+            <a:schemeClr val="lt1"/>
+          </a:fontRef>
+        </p:style>
+        <p:txBody>
+          <a:bodyPr rtlCol="0" anchor="ctr" wrap="square" lIns="182880" rIns="182880" tIns="182880" bIns="182880"/>
+          <a:lstStyle/>
+          <a:p>
+            <a:pPr algn="ctr">
+              <a:spcAft>
+                <a:spcPts val="600"/>
+              </a:spcAft>
+              <a:defRPr sz="1350" b="1">
+                <a:solidFill>
+                  <a:srgbClr val="10B981"/>
+                </a:solidFill>
+                <a:latin typeface="Arial"/>
+              </a:defRPr>
+            </a:pPr>
+            <a:r>
+              <a:t>3. DATA AGENT 📊</a:t>
+            </a:r>
+          </a:p>
+          <a:p>
+            <a:pPr>
+              <a:spcBef>
+                <a:spcPts val="300"/>
+              </a:spcBef>
+              <a:defRPr sz="1000">
+                <a:solidFill>
+                  <a:srgbClr val="F8FAFC"/>
+                </a:solidFill>
+                <a:latin typeface="Arial"/>
+              </a:defRPr>
+            </a:pPr>
+            <a:r>
+              <a:t>Executes safe Gold SQL</a:t>
+            </a:r>
+          </a:p>
+        </p:txBody>
+      </p:sp>
+      <p:sp>
+        <p:nvSpPr>
+          <p:cNvPr id="9" name="TextBox 8"/>
+          <p:cNvSpPr txBox="1"/>
+          <p:nvPr/>
+        </p:nvSpPr>
+        <p:spPr>
+          <a:xfrm>
+            <a:off x="7004304" y="2194560"/>
+            <a:ext cx="393192" cy="548640"/>
+          </a:xfrm>
+          <a:prstGeom prst="rect">
+            <a:avLst/>
+          </a:prstGeom>
+          <a:noFill/>
+        </p:spPr>
+        <p:txBody>
+          <a:bodyPr wrap="none">
+            <a:spAutoFit/>
+          </a:bodyPr>
+          <a:lstStyle/>
+          <a:p>
+            <a:pPr algn="ctr">
+              <a:defRPr sz="1800" b="1">
+                <a:solidFill>
+                  <a:srgbClr val="6366F1"/>
+                </a:solidFill>
+                <a:latin typeface="Arial"/>
+              </a:defRPr>
+            </a:pPr>
+            <a:r>
+              <a:t>➔</a:t>
+            </a:r>
+          </a:p>
+        </p:txBody>
+      </p:sp>
+      <p:sp>
+        <p:nvSpPr>
+          <p:cNvPr id="10" name="Rounded Rectangle 9"/>
+          <p:cNvSpPr/>
+          <p:nvPr/>
+        </p:nvSpPr>
+        <p:spPr>
+          <a:xfrm>
+            <a:off x="7397496" y="1463040"/>
+            <a:ext cx="1828800" cy="2011680"/>
+          </a:xfrm>
+          <a:prstGeom prst="roundRect">
+            <a:avLst/>
+          </a:prstGeom>
+          <a:solidFill>
+            <a:srgbClr val="1E293B"/>
+          </a:solidFill>
+          <a:ln w="12700">
+            <a:solidFill>
+              <a:srgbClr val="F59E0B"/>
+            </a:solidFill>
+          </a:ln>
+        </p:spPr>
+        <p:style>
+          <a:lnRef idx="1">
+            <a:schemeClr val="accent1"/>
+          </a:lnRef>
+          <a:fillRef idx="3">
+            <a:schemeClr val="accent1"/>
+          </a:fillRef>
+          <a:effectRef idx="2">
+            <a:schemeClr val="accent1"/>
+          </a:effectRef>
+          <a:fontRef idx="minor">
+            <a:schemeClr val="lt1"/>
+          </a:fontRef>
+        </p:style>
+        <p:txBody>
+          <a:bodyPr rtlCol="0" anchor="ctr" wrap="square" lIns="182880" rIns="182880" tIns="182880" bIns="182880"/>
+          <a:lstStyle/>
+          <a:p>
+            <a:pPr algn="ctr">
+              <a:spcAft>
+                <a:spcPts val="600"/>
+              </a:spcAft>
+              <a:defRPr sz="1350" b="1">
+                <a:solidFill>
+                  <a:srgbClr val="F59E0B"/>
+                </a:solidFill>
+                <a:latin typeface="Arial"/>
+              </a:defRPr>
+            </a:pPr>
+            <a:r>
+              <a:t>4. INSIGHT AGENT 💡</a:t>
+            </a:r>
+          </a:p>
+          <a:p>
+            <a:pPr>
+              <a:spcBef>
+                <a:spcPts val="300"/>
+              </a:spcBef>
+              <a:defRPr sz="1000">
+                <a:solidFill>
+                  <a:srgbClr val="F8FAFC"/>
+                </a:solidFill>
+                <a:latin typeface="Arial"/>
+              </a:defRPr>
+            </a:pPr>
+            <a:r>
+              <a:t>Explains 12% category drop</a:t>
+            </a:r>
+          </a:p>
+        </p:txBody>
+      </p:sp>
+      <p:sp>
+        <p:nvSpPr>
+          <p:cNvPr id="11" name="TextBox 10"/>
+          <p:cNvSpPr txBox="1"/>
+          <p:nvPr/>
+        </p:nvSpPr>
+        <p:spPr>
+          <a:xfrm>
+            <a:off x="9226296" y="2194560"/>
+            <a:ext cx="393192" cy="548640"/>
+          </a:xfrm>
+          <a:prstGeom prst="rect">
+            <a:avLst/>
+          </a:prstGeom>
+          <a:noFill/>
+        </p:spPr>
+        <p:txBody>
+          <a:bodyPr wrap="none">
+            <a:spAutoFit/>
+          </a:bodyPr>
+          <a:lstStyle/>
+          <a:p>
+            <a:pPr algn="ctr">
+              <a:defRPr sz="1800" b="1">
+                <a:solidFill>
+                  <a:srgbClr val="6366F1"/>
+                </a:solidFill>
+                <a:latin typeface="Arial"/>
+              </a:defRPr>
+            </a:pPr>
+            <a:r>
+              <a:t>➔</a:t>
+            </a:r>
+          </a:p>
+        </p:txBody>
+      </p:sp>
+      <p:sp>
+        <p:nvSpPr>
+          <p:cNvPr id="12" name="Rounded Rectangle 11"/>
+          <p:cNvSpPr/>
+          <p:nvPr/>
+        </p:nvSpPr>
+        <p:spPr>
+          <a:xfrm>
+            <a:off x="9619488" y="1463040"/>
+            <a:ext cx="1828800" cy="2011680"/>
+          </a:xfrm>
+          <a:prstGeom prst="roundRect">
+            <a:avLst/>
+          </a:prstGeom>
+          <a:solidFill>
+            <a:srgbClr val="1E293B"/>
+          </a:solidFill>
+          <a:ln w="12700">
+            <a:solidFill>
+              <a:srgbClr val="DB2777"/>
+            </a:solidFill>
+          </a:ln>
+        </p:spPr>
+        <p:style>
+          <a:lnRef idx="1">
+            <a:schemeClr val="accent1"/>
+          </a:lnRef>
+          <a:fillRef idx="3">
+            <a:schemeClr val="accent1"/>
+          </a:fillRef>
+          <a:effectRef idx="2">
+            <a:schemeClr val="accent1"/>
+          </a:effectRef>
+          <a:fontRef idx="minor">
+            <a:schemeClr val="lt1"/>
+          </a:fontRef>
+        </p:style>
+        <p:txBody>
+          <a:bodyPr rtlCol="0" anchor="ctr" wrap="square" lIns="182880" rIns="182880" tIns="182880" bIns="182880"/>
+          <a:lstStyle/>
+          <a:p>
+            <a:pPr algn="ctr">
+              <a:spcAft>
+                <a:spcPts val="600"/>
+              </a:spcAft>
+              <a:defRPr sz="1350" b="1">
+                <a:solidFill>
+                  <a:srgbClr val="DB2777"/>
+                </a:solidFill>
+                <a:latin typeface="Arial"/>
+              </a:defRPr>
+            </a:pPr>
+            <a:r>
+              <a:t>5. ACTION AGENT 🎯</a:t>
+            </a:r>
+          </a:p>
+          <a:p>
+            <a:pPr>
+              <a:spcBef>
+                <a:spcPts val="300"/>
+              </a:spcBef>
+              <a:defRPr sz="1000">
+                <a:solidFill>
+                  <a:srgbClr val="F8FAFC"/>
+                </a:solidFill>
+                <a:latin typeface="Arial"/>
+              </a:defRPr>
+            </a:pPr>
+            <a:r>
+              <a:t>Recommends promo bundles</a:t>
+            </a:r>
+          </a:p>
+        </p:txBody>
+      </p:sp>
+      <p:sp>
+        <p:nvSpPr>
+          <p:cNvPr id="13" name="Rounded Rectangle 12"/>
+          <p:cNvSpPr/>
+          <p:nvPr/>
+        </p:nvSpPr>
+        <p:spPr>
+          <a:xfrm>
+            <a:off x="731520" y="3840480"/>
+            <a:ext cx="10728655" cy="2377440"/>
           </a:xfrm>
           <a:prstGeom prst="roundRect">
             <a:avLst/>
@@ -5731,7 +6635,7 @@
               </a:defRPr>
             </a:pPr>
             <a:r>
-              <a:t>HOW AGENTS CHAIN TOGETHER</a:t>
+              <a:t>HOW CONTEXT FORWARDING WORKS BETWEEN AGENTS</a:t>
             </a:r>
           </a:p>
           <a:p>
@@ -5750,13 +6654,16 @@
               <a:t>1. User Question → Auto Router analyzes intent and selects agent sequence (e.g. ['data', 'insight', 'action']).</a:t>
             </a:r>
             <a:br/>
+            <a:br/>
             <a:r>
               <a:t>2. Data Agent executes safe SQL against Gold schema → Passes query results as context to Insight Agent.</a:t>
             </a:r>
             <a:br/>
+            <a:br/>
             <a:r>
               <a:t>3. Insight Agent derives evidence-backed business insights → Passes insight as context to Action Agent.</a:t>
             </a:r>
+            <a:br/>
             <a:br/>
             <a:r>
               <a:t>4. Action Agent formulates specific management recommendations → Streamlit UI renders formatted response cards.</a:t>

</xml_diff>